<commit_message>
Refactor epoch ranking output and labels
Fixes and refactors how epoch similarities and rankings are labeled and rendered. Updates plot y-labels from "Pearson" to "Spearman", makes CSV headers friendlier (e.g. "Epoch", "Min. Loss", "Corr. Top 3") and writes numeric epoch rows instead of "epoch_N". Reworks the image table generation: combines epoch column with min/correlation columns, adds a separate right-hand final-ranking table with highlighted header, and adjusts figure sizing/layout. Also initializes summaries before computing epoch similarity and changes the main() default dataset to "BT". Regenerated related assets (CSV, PNGs, PPTX) included.
</commit_message>
<xml_diff>
--- a/other/sunum.pptx
+++ b/other/sunum.pptx
@@ -7,6 +7,15 @@
   <p:sldIdLst>
     <p:sldId id="256" r:id="rId2"/>
     <p:sldId id="257" r:id="rId3"/>
+    <p:sldId id="258" r:id="rId4"/>
+    <p:sldId id="259" r:id="rId5"/>
+    <p:sldId id="260" r:id="rId6"/>
+    <p:sldId id="262" r:id="rId7"/>
+    <p:sldId id="263" r:id="rId8"/>
+    <p:sldId id="264" r:id="rId9"/>
+    <p:sldId id="265" r:id="rId10"/>
+    <p:sldId id="266" r:id="rId11"/>
+    <p:sldId id="261" r:id="rId12"/>
   </p:sldIdLst>
   <p:sldSz cx="12192000" cy="6858000"/>
   <p:notesSz cx="6858000" cy="9144000"/>
@@ -105,6 +114,11 @@
       </a:defRPr>
     </a:lvl9pPr>
   </p:defaultTextStyle>
+  <p:extLst>
+    <p:ext uri="{EFAFB233-063F-42B5-8137-9DF3F51BA10A}">
+      <p15:sldGuideLst xmlns:p15="http://schemas.microsoft.com/office/powerpoint/2012/main"/>
+    </p:ext>
+  </p:extLst>
 </p:presentation>
 </file>
 
@@ -293,7 +307,7 @@
           <a:p>
             <a:fld id="{3E0254F8-EA1E-4190-9E7C-C0EBFFD65A44}" type="datetimeFigureOut">
               <a:rPr lang="tr-TR" smtClean="0"/>
-              <a:t>10.03.2026</a:t>
+              <a:t>11.03.2026</a:t>
             </a:fld>
             <a:endParaRPr lang="tr-TR"/>
           </a:p>
@@ -591,7 +605,7 @@
           <a:p>
             <a:fld id="{3E0254F8-EA1E-4190-9E7C-C0EBFFD65A44}" type="datetimeFigureOut">
               <a:rPr lang="tr-TR" smtClean="0"/>
-              <a:t>10.03.2026</a:t>
+              <a:t>11.03.2026</a:t>
             </a:fld>
             <a:endParaRPr lang="tr-TR"/>
           </a:p>
@@ -783,7 +797,7 @@
           <a:p>
             <a:fld id="{3E0254F8-EA1E-4190-9E7C-C0EBFFD65A44}" type="datetimeFigureOut">
               <a:rPr lang="tr-TR" smtClean="0"/>
-              <a:t>10.03.2026</a:t>
+              <a:t>11.03.2026</a:t>
             </a:fld>
             <a:endParaRPr lang="tr-TR"/>
           </a:p>
@@ -1044,7 +1058,7 @@
           <a:p>
             <a:fld id="{3E0254F8-EA1E-4190-9E7C-C0EBFFD65A44}" type="datetimeFigureOut">
               <a:rPr lang="tr-TR" smtClean="0"/>
-              <a:t>10.03.2026</a:t>
+              <a:t>11.03.2026</a:t>
             </a:fld>
             <a:endParaRPr lang="tr-TR"/>
           </a:p>
@@ -1468,7 +1482,7 @@
           <a:p>
             <a:fld id="{3E0254F8-EA1E-4190-9E7C-C0EBFFD65A44}" type="datetimeFigureOut">
               <a:rPr lang="tr-TR" smtClean="0"/>
-              <a:t>10.03.2026</a:t>
+              <a:t>11.03.2026</a:t>
             </a:fld>
             <a:endParaRPr lang="tr-TR"/>
           </a:p>
@@ -2005,7 +2019,7 @@
           <a:p>
             <a:fld id="{3E0254F8-EA1E-4190-9E7C-C0EBFFD65A44}" type="datetimeFigureOut">
               <a:rPr lang="tr-TR" smtClean="0"/>
-              <a:t>10.03.2026</a:t>
+              <a:t>11.03.2026</a:t>
             </a:fld>
             <a:endParaRPr lang="tr-TR"/>
           </a:p>
@@ -2869,7 +2883,7 @@
           <a:p>
             <a:fld id="{3E0254F8-EA1E-4190-9E7C-C0EBFFD65A44}" type="datetimeFigureOut">
               <a:rPr lang="tr-TR" smtClean="0"/>
-              <a:t>10.03.2026</a:t>
+              <a:t>11.03.2026</a:t>
             </a:fld>
             <a:endParaRPr lang="tr-TR"/>
           </a:p>
@@ -3039,7 +3053,7 @@
           <a:p>
             <a:fld id="{3E0254F8-EA1E-4190-9E7C-C0EBFFD65A44}" type="datetimeFigureOut">
               <a:rPr lang="tr-TR" smtClean="0"/>
-              <a:t>10.03.2026</a:t>
+              <a:t>11.03.2026</a:t>
             </a:fld>
             <a:endParaRPr lang="tr-TR"/>
           </a:p>
@@ -3223,7 +3237,7 @@
           <a:p>
             <a:fld id="{3E0254F8-EA1E-4190-9E7C-C0EBFFD65A44}" type="datetimeFigureOut">
               <a:rPr lang="tr-TR" smtClean="0"/>
-              <a:t>10.03.2026</a:t>
+              <a:t>11.03.2026</a:t>
             </a:fld>
             <a:endParaRPr lang="tr-TR"/>
           </a:p>
@@ -3393,7 +3407,7 @@
           <a:p>
             <a:fld id="{3E0254F8-EA1E-4190-9E7C-C0EBFFD65A44}" type="datetimeFigureOut">
               <a:rPr lang="tr-TR" smtClean="0"/>
-              <a:t>10.03.2026</a:t>
+              <a:t>11.03.2026</a:t>
             </a:fld>
             <a:endParaRPr lang="tr-TR"/>
           </a:p>
@@ -3637,7 +3651,7 @@
           <a:p>
             <a:fld id="{3E0254F8-EA1E-4190-9E7C-C0EBFFD65A44}" type="datetimeFigureOut">
               <a:rPr lang="tr-TR" smtClean="0"/>
-              <a:t>10.03.2026</a:t>
+              <a:t>11.03.2026</a:t>
             </a:fld>
             <a:endParaRPr lang="tr-TR"/>
           </a:p>
@@ -3873,7 +3887,7 @@
           <a:p>
             <a:fld id="{3E0254F8-EA1E-4190-9E7C-C0EBFFD65A44}" type="datetimeFigureOut">
               <a:rPr lang="tr-TR" smtClean="0"/>
-              <a:t>10.03.2026</a:t>
+              <a:t>11.03.2026</a:t>
             </a:fld>
             <a:endParaRPr lang="tr-TR"/>
           </a:p>
@@ -4339,7 +4353,7 @@
           <a:p>
             <a:fld id="{3E0254F8-EA1E-4190-9E7C-C0EBFFD65A44}" type="datetimeFigureOut">
               <a:rPr lang="tr-TR" smtClean="0"/>
-              <a:t>10.03.2026</a:t>
+              <a:t>11.03.2026</a:t>
             </a:fld>
             <a:endParaRPr lang="tr-TR"/>
           </a:p>
@@ -4457,7 +4471,7 @@
           <a:p>
             <a:fld id="{3E0254F8-EA1E-4190-9E7C-C0EBFFD65A44}" type="datetimeFigureOut">
               <a:rPr lang="tr-TR" smtClean="0"/>
-              <a:t>10.03.2026</a:t>
+              <a:t>11.03.2026</a:t>
             </a:fld>
             <a:endParaRPr lang="tr-TR"/>
           </a:p>
@@ -4552,7 +4566,7 @@
           <a:p>
             <a:fld id="{3E0254F8-EA1E-4190-9E7C-C0EBFFD65A44}" type="datetimeFigureOut">
               <a:rPr lang="tr-TR" smtClean="0"/>
-              <a:t>10.03.2026</a:t>
+              <a:t>11.03.2026</a:t>
             </a:fld>
             <a:endParaRPr lang="tr-TR"/>
           </a:p>
@@ -4807,7 +4821,7 @@
           <a:p>
             <a:fld id="{3E0254F8-EA1E-4190-9E7C-C0EBFFD65A44}" type="datetimeFigureOut">
               <a:rPr lang="tr-TR" smtClean="0"/>
-              <a:t>10.03.2026</a:t>
+              <a:t>11.03.2026</a:t>
             </a:fld>
             <a:endParaRPr lang="tr-TR"/>
           </a:p>
@@ -5107,7 +5121,7 @@
           <a:p>
             <a:fld id="{3E0254F8-EA1E-4190-9E7C-C0EBFFD65A44}" type="datetimeFigureOut">
               <a:rPr lang="tr-TR" smtClean="0"/>
-              <a:t>10.03.2026</a:t>
+              <a:t>11.03.2026</a:t>
             </a:fld>
             <a:endParaRPr lang="tr-TR"/>
           </a:p>
@@ -5341,7 +5355,7 @@
           <a:p>
             <a:fld id="{3E0254F8-EA1E-4190-9E7C-C0EBFFD65A44}" type="datetimeFigureOut">
               <a:rPr lang="tr-TR" smtClean="0"/>
-              <a:t>10.03.2026</a:t>
+              <a:t>11.03.2026</a:t>
             </a:fld>
             <a:endParaRPr lang="tr-TR"/>
           </a:p>
@@ -6685,7 +6699,7 @@
               </a:lnSpc>
             </a:pPr>
             <a:r>
-              <a:rPr lang="de-DE" sz="5000" b="1"/>
+              <a:rPr lang="de-DE" sz="5000" b="1" dirty="0"/>
               <a:t>CNN Modellerinde Performans Sıralamasının Erken Stabilizasyonunun Analizi ve Optimum Epoch Belirlenmesi</a:t>
             </a:r>
             <a:endParaRPr lang="tr-TR" sz="5000" b="1" dirty="0"/>
@@ -6696,6 +6710,174 @@
     <p:extLst>
       <p:ext uri="{BB962C8B-B14F-4D97-AF65-F5344CB8AC3E}">
         <p14:creationId xmlns:p14="http://schemas.microsoft.com/office/powerpoint/2010/main" val="2513961125"/>
+      </p:ext>
+    </p:extLst>
+  </p:cSld>
+  <p:clrMapOvr>
+    <a:masterClrMapping/>
+  </p:clrMapOvr>
+</p:sld>
+</file>
+
+<file path=ppt/slides/slide10.xml><?xml version="1.0" encoding="utf-8"?>
+<p:sld xmlns:a="http://schemas.openxmlformats.org/drawingml/2006/main" xmlns:r="http://schemas.openxmlformats.org/officeDocument/2006/relationships" xmlns:p="http://schemas.openxmlformats.org/presentationml/2006/main">
+  <p:cSld>
+    <p:spTree>
+      <p:nvGrpSpPr>
+        <p:cNvPr id="1" name=""/>
+        <p:cNvGrpSpPr/>
+        <p:nvPr/>
+      </p:nvGrpSpPr>
+      <p:grpSpPr>
+        <a:xfrm>
+          <a:off x="0" y="0"/>
+          <a:ext cx="0" cy="0"/>
+          <a:chOff x="0" y="0"/>
+          <a:chExt cx="0" cy="0"/>
+        </a:xfrm>
+      </p:grpSpPr>
+      <p:sp>
+        <p:nvSpPr>
+          <p:cNvPr id="2" name="Title 1">
+            <a:extLst>
+              <a:ext uri="{FF2B5EF4-FFF2-40B4-BE49-F238E27FC236}">
+                <a16:creationId xmlns:a16="http://schemas.microsoft.com/office/drawing/2014/main" id="{A321B401-A64A-6543-2C56-ADF18AE68C10}"/>
+              </a:ext>
+            </a:extLst>
+          </p:cNvPr>
+          <p:cNvSpPr>
+            <a:spLocks noGrp="1"/>
+          </p:cNvSpPr>
+          <p:nvPr>
+            <p:ph type="title"/>
+          </p:nvPr>
+        </p:nvSpPr>
+        <p:spPr/>
+        <p:txBody>
+          <a:bodyPr/>
+          <a:lstStyle/>
+          <a:p>
+            <a:r>
+              <a:rPr lang="tr-TR" dirty="0"/>
+              <a:t>9. Deney Sonuçları</a:t>
+            </a:r>
+          </a:p>
+        </p:txBody>
+      </p:sp>
+    </p:spTree>
+    <p:extLst>
+      <p:ext uri="{BB962C8B-B14F-4D97-AF65-F5344CB8AC3E}">
+        <p14:creationId xmlns:p14="http://schemas.microsoft.com/office/powerpoint/2010/main" val="1405843126"/>
+      </p:ext>
+    </p:extLst>
+  </p:cSld>
+  <p:clrMapOvr>
+    <a:masterClrMapping/>
+  </p:clrMapOvr>
+</p:sld>
+</file>
+
+<file path=ppt/slides/slide11.xml><?xml version="1.0" encoding="utf-8"?>
+<p:sld xmlns:a="http://schemas.openxmlformats.org/drawingml/2006/main" xmlns:r="http://schemas.openxmlformats.org/officeDocument/2006/relationships" xmlns:p="http://schemas.openxmlformats.org/presentationml/2006/main">
+  <p:cSld>
+    <p:spTree>
+      <p:nvGrpSpPr>
+        <p:cNvPr id="1" name=""/>
+        <p:cNvGrpSpPr/>
+        <p:nvPr/>
+      </p:nvGrpSpPr>
+      <p:grpSpPr>
+        <a:xfrm>
+          <a:off x="0" y="0"/>
+          <a:ext cx="0" cy="0"/>
+          <a:chOff x="0" y="0"/>
+          <a:chExt cx="0" cy="0"/>
+        </a:xfrm>
+      </p:grpSpPr>
+      <p:sp>
+        <p:nvSpPr>
+          <p:cNvPr id="2" name="Title 1">
+            <a:extLst>
+              <a:ext uri="{FF2B5EF4-FFF2-40B4-BE49-F238E27FC236}">
+                <a16:creationId xmlns:a16="http://schemas.microsoft.com/office/drawing/2014/main" id="{102A5A02-C387-3EEE-1C98-6F255751CF92}"/>
+              </a:ext>
+            </a:extLst>
+          </p:cNvPr>
+          <p:cNvSpPr>
+            <a:spLocks noGrp="1"/>
+          </p:cNvSpPr>
+          <p:nvPr>
+            <p:ph type="title"/>
+          </p:nvPr>
+        </p:nvSpPr>
+        <p:spPr/>
+        <p:txBody>
+          <a:bodyPr/>
+          <a:lstStyle/>
+          <a:p>
+            <a:r>
+              <a:rPr lang="tr-TR" dirty="0"/>
+              <a:t>Gelecek Çalışmalar</a:t>
+            </a:r>
+          </a:p>
+        </p:txBody>
+      </p:sp>
+      <p:sp>
+        <p:nvSpPr>
+          <p:cNvPr id="3" name="Content Placeholder 2">
+            <a:extLst>
+              <a:ext uri="{FF2B5EF4-FFF2-40B4-BE49-F238E27FC236}">
+                <a16:creationId xmlns:a16="http://schemas.microsoft.com/office/drawing/2014/main" id="{E2936CDE-3FBD-FD5A-F0C6-689218CBA957}"/>
+              </a:ext>
+            </a:extLst>
+          </p:cNvPr>
+          <p:cNvSpPr>
+            <a:spLocks noGrp="1"/>
+          </p:cNvSpPr>
+          <p:nvPr>
+            <p:ph idx="1"/>
+          </p:nvPr>
+        </p:nvSpPr>
+        <p:spPr/>
+        <p:txBody>
+          <a:bodyPr/>
+          <a:lstStyle/>
+          <a:p>
+            <a:pPr marL="36900" indent="0">
+              <a:buNone/>
+            </a:pPr>
+            <a:r>
+              <a:rPr lang="tr-TR" dirty="0"/>
+              <a:t>Gelecekte yapılabilecek çalışmalar:</a:t>
+            </a:r>
+          </a:p>
+          <a:p>
+            <a:r>
+              <a:rPr lang="tr-TR" dirty="0"/>
+              <a:t>Daha farklı veri setleri ile deneylerin tekrarlanması</a:t>
+            </a:r>
+          </a:p>
+          <a:p>
+            <a:r>
+              <a:rPr lang="tr-TR" dirty="0"/>
+              <a:t>Model çeşitliliği artırılarak deneylerin tekrar edilmesi</a:t>
+            </a:r>
+          </a:p>
+          <a:p>
+            <a:r>
+              <a:rPr lang="tr-TR" dirty="0"/>
+              <a:t>Farklı performans metriklerinin incelenmesi</a:t>
+            </a:r>
+          </a:p>
+          <a:p>
+            <a:endParaRPr lang="tr-TR" dirty="0"/>
+          </a:p>
+        </p:txBody>
+      </p:sp>
+    </p:spTree>
+    <p:extLst>
+      <p:ext uri="{BB962C8B-B14F-4D97-AF65-F5344CB8AC3E}">
+        <p14:creationId xmlns:p14="http://schemas.microsoft.com/office/powerpoint/2010/main" val="3464479053"/>
       </p:ext>
     </p:extLst>
   </p:cSld>
@@ -6743,7 +6925,10 @@
           <a:bodyPr/>
           <a:lstStyle/>
           <a:p>
-            <a:endParaRPr lang="tr-TR"/>
+            <a:r>
+              <a:rPr lang="tr-TR" dirty="0"/>
+              <a:t>1. Problem Tanımı</a:t>
+            </a:r>
           </a:p>
         </p:txBody>
       </p:sp>
@@ -6768,7 +6953,46 @@
           <a:bodyPr/>
           <a:lstStyle/>
           <a:p>
-            <a:endParaRPr lang="tr-TR"/>
+            <a:pPr marL="36900" indent="0">
+              <a:buNone/>
+            </a:pPr>
+            <a:r>
+              <a:rPr lang="tr-TR" dirty="0"/>
+              <a:t>Derin öğrenme modellerinin eğitimi genellikle yüksek hesaplama maliyeti gerektirir.</a:t>
+            </a:r>
+          </a:p>
+          <a:p>
+            <a:pPr marL="36900" indent="0">
+              <a:buNone/>
+            </a:pPr>
+            <a:r>
+              <a:rPr lang="tr-TR" dirty="0"/>
+              <a:t>Model seçimi çoğunlukla:</a:t>
+            </a:r>
+          </a:p>
+          <a:p>
+            <a:r>
+              <a:rPr lang="tr-TR" dirty="0"/>
+              <a:t>Tüm modeller tamamen eğitildikten sonra yapılmaktadır.</a:t>
+            </a:r>
+          </a:p>
+          <a:p>
+            <a:r>
+              <a:rPr lang="tr-TR" dirty="0"/>
+              <a:t>Bu durum gereksiz zaman ve hesaplama maliyetine yol açabilmektedir.</a:t>
+            </a:r>
+          </a:p>
+          <a:p>
+            <a:pPr marL="36900" indent="0">
+              <a:buNone/>
+            </a:pPr>
+            <a:r>
+              <a:rPr lang="tr-TR" dirty="0"/>
+              <a:t>Bu nedenle eğitim sürecinde model performans sıralamasının erken aşamalarda belirlenip belirlenemeyeceği önemli bir araştırma konusudur.</a:t>
+            </a:r>
+          </a:p>
+          <a:p>
+            <a:endParaRPr lang="tr-TR" dirty="0"/>
           </a:p>
         </p:txBody>
       </p:sp>
@@ -6776,6 +7000,1154 @@
     <p:extLst>
       <p:ext uri="{BB962C8B-B14F-4D97-AF65-F5344CB8AC3E}">
         <p14:creationId xmlns:p14="http://schemas.microsoft.com/office/powerpoint/2010/main" val="2241263693"/>
+      </p:ext>
+    </p:extLst>
+  </p:cSld>
+  <p:clrMapOvr>
+    <a:masterClrMapping/>
+  </p:clrMapOvr>
+</p:sld>
+</file>
+
+<file path=ppt/slides/slide3.xml><?xml version="1.0" encoding="utf-8"?>
+<p:sld xmlns:a="http://schemas.openxmlformats.org/drawingml/2006/main" xmlns:r="http://schemas.openxmlformats.org/officeDocument/2006/relationships" xmlns:p="http://schemas.openxmlformats.org/presentationml/2006/main">
+  <p:cSld>
+    <p:spTree>
+      <p:nvGrpSpPr>
+        <p:cNvPr id="1" name=""/>
+        <p:cNvGrpSpPr/>
+        <p:nvPr/>
+      </p:nvGrpSpPr>
+      <p:grpSpPr>
+        <a:xfrm>
+          <a:off x="0" y="0"/>
+          <a:ext cx="0" cy="0"/>
+          <a:chOff x="0" y="0"/>
+          <a:chExt cx="0" cy="0"/>
+        </a:xfrm>
+      </p:grpSpPr>
+      <p:sp>
+        <p:nvSpPr>
+          <p:cNvPr id="2" name="Title 1">
+            <a:extLst>
+              <a:ext uri="{FF2B5EF4-FFF2-40B4-BE49-F238E27FC236}">
+                <a16:creationId xmlns:a16="http://schemas.microsoft.com/office/drawing/2014/main" id="{9968FC1D-858D-F94D-65E0-EF507595A86E}"/>
+              </a:ext>
+            </a:extLst>
+          </p:cNvPr>
+          <p:cNvSpPr>
+            <a:spLocks noGrp="1"/>
+          </p:cNvSpPr>
+          <p:nvPr>
+            <p:ph type="title"/>
+          </p:nvPr>
+        </p:nvSpPr>
+        <p:spPr/>
+        <p:txBody>
+          <a:bodyPr/>
+          <a:lstStyle/>
+          <a:p>
+            <a:r>
+              <a:rPr lang="tr-TR" dirty="0"/>
+              <a:t>2. Çalışmanın Amacı</a:t>
+            </a:r>
+          </a:p>
+        </p:txBody>
+      </p:sp>
+      <p:sp>
+        <p:nvSpPr>
+          <p:cNvPr id="3" name="Content Placeholder 2">
+            <a:extLst>
+              <a:ext uri="{FF2B5EF4-FFF2-40B4-BE49-F238E27FC236}">
+                <a16:creationId xmlns:a16="http://schemas.microsoft.com/office/drawing/2014/main" id="{1BFC2929-8BB3-5668-FF28-21B11F8A12E4}"/>
+              </a:ext>
+            </a:extLst>
+          </p:cNvPr>
+          <p:cNvSpPr>
+            <a:spLocks noGrp="1"/>
+          </p:cNvSpPr>
+          <p:nvPr>
+            <p:ph idx="1"/>
+          </p:nvPr>
+        </p:nvSpPr>
+        <p:spPr/>
+        <p:txBody>
+          <a:bodyPr/>
+          <a:lstStyle/>
+          <a:p>
+            <a:pPr marL="36900" indent="0">
+              <a:buNone/>
+            </a:pPr>
+            <a:r>
+              <a:rPr lang="tr-TR" dirty="0"/>
+              <a:t>Bu çalışmanın amacı:</a:t>
+            </a:r>
+          </a:p>
+          <a:p>
+            <a:r>
+              <a:rPr lang="tr-TR" dirty="0"/>
+              <a:t>Farklı CNN modellerinin eğitim sürecindeki performans sıralamalarını incelemek</a:t>
+            </a:r>
+          </a:p>
+          <a:p>
+            <a:r>
+              <a:rPr lang="tr-TR" dirty="0"/>
+              <a:t>Nihai performans sıralamasının eğitim sürecinin hangi aşamasında stabil hale geldiğini belirlemek</a:t>
+            </a:r>
+          </a:p>
+          <a:p>
+            <a:r>
+              <a:rPr lang="tr-TR" dirty="0"/>
+              <a:t>Model seçimi için gerekli </a:t>
+            </a:r>
+            <a:r>
+              <a:rPr lang="tr-TR" b="1" dirty="0"/>
+              <a:t>minimum epoch sayısını tespit etmektir</a:t>
+            </a:r>
+            <a:endParaRPr lang="tr-TR" dirty="0"/>
+          </a:p>
+          <a:p>
+            <a:endParaRPr lang="tr-TR" dirty="0"/>
+          </a:p>
+        </p:txBody>
+      </p:sp>
+    </p:spTree>
+    <p:extLst>
+      <p:ext uri="{BB962C8B-B14F-4D97-AF65-F5344CB8AC3E}">
+        <p14:creationId xmlns:p14="http://schemas.microsoft.com/office/powerpoint/2010/main" val="587804600"/>
+      </p:ext>
+    </p:extLst>
+  </p:cSld>
+  <p:clrMapOvr>
+    <a:masterClrMapping/>
+  </p:clrMapOvr>
+</p:sld>
+</file>
+
+<file path=ppt/slides/slide4.xml><?xml version="1.0" encoding="utf-8"?>
+<p:sld xmlns:a="http://schemas.openxmlformats.org/drawingml/2006/main" xmlns:r="http://schemas.openxmlformats.org/officeDocument/2006/relationships" xmlns:p="http://schemas.openxmlformats.org/presentationml/2006/main">
+  <p:cSld>
+    <p:bg>
+      <p:bgPr>
+        <a:blipFill rotWithShape="1">
+          <a:blip r:embed="rId2">
+            <a:duotone>
+              <a:schemeClr val="bg2">
+                <a:shade val="80000"/>
+                <a:lumMod val="80000"/>
+              </a:schemeClr>
+              <a:schemeClr val="bg2">
+                <a:tint val="98000"/>
+              </a:schemeClr>
+            </a:duotone>
+          </a:blip>
+          <a:stretch/>
+        </a:blipFill>
+        <a:effectLst/>
+      </p:bgPr>
+    </p:bg>
+    <p:spTree>
+      <p:nvGrpSpPr>
+        <p:cNvPr id="1" name=""/>
+        <p:cNvGrpSpPr/>
+        <p:nvPr/>
+      </p:nvGrpSpPr>
+      <p:grpSpPr>
+        <a:xfrm>
+          <a:off x="0" y="0"/>
+          <a:ext cx="0" cy="0"/>
+          <a:chOff x="0" y="0"/>
+          <a:chExt cx="0" cy="0"/>
+        </a:xfrm>
+      </p:grpSpPr>
+      <p:sp>
+        <p:nvSpPr>
+          <p:cNvPr id="2" name="Title 1">
+            <a:extLst>
+              <a:ext uri="{FF2B5EF4-FFF2-40B4-BE49-F238E27FC236}">
+                <a16:creationId xmlns:a16="http://schemas.microsoft.com/office/drawing/2014/main" id="{7791AC15-B075-D165-28B1-13E6169C492E}"/>
+              </a:ext>
+            </a:extLst>
+          </p:cNvPr>
+          <p:cNvSpPr>
+            <a:spLocks noGrp="1"/>
+          </p:cNvSpPr>
+          <p:nvPr>
+            <p:ph type="title"/>
+          </p:nvPr>
+        </p:nvSpPr>
+        <p:spPr>
+          <a:xfrm>
+            <a:off x="913795" y="609600"/>
+            <a:ext cx="10353762" cy="970450"/>
+          </a:xfrm>
+        </p:spPr>
+        <p:txBody>
+          <a:bodyPr>
+            <a:normAutofit/>
+          </a:bodyPr>
+          <a:lstStyle/>
+          <a:p>
+            <a:r>
+              <a:rPr lang="tr-TR" dirty="0"/>
+              <a:t>3. Veri Seti</a:t>
+            </a:r>
+          </a:p>
+        </p:txBody>
+      </p:sp>
+      <p:sp>
+        <p:nvSpPr>
+          <p:cNvPr id="3" name="Content Placeholder 2">
+            <a:extLst>
+              <a:ext uri="{FF2B5EF4-FFF2-40B4-BE49-F238E27FC236}">
+                <a16:creationId xmlns:a16="http://schemas.microsoft.com/office/drawing/2014/main" id="{C01B9950-2B73-4D63-BCB1-7524EAA78542}"/>
+              </a:ext>
+            </a:extLst>
+          </p:cNvPr>
+          <p:cNvSpPr>
+            <a:spLocks noGrp="1"/>
+          </p:cNvSpPr>
+          <p:nvPr>
+            <p:ph idx="1"/>
+          </p:nvPr>
+        </p:nvSpPr>
+        <p:spPr>
+          <a:xfrm>
+            <a:off x="913795" y="1732449"/>
+            <a:ext cx="5546272" cy="4058751"/>
+          </a:xfrm>
+        </p:spPr>
+        <p:txBody>
+          <a:bodyPr anchor="ctr">
+            <a:normAutofit/>
+          </a:bodyPr>
+          <a:lstStyle/>
+          <a:p>
+            <a:pPr marL="36900" indent="0">
+              <a:lnSpc>
+                <a:spcPct val="90000"/>
+              </a:lnSpc>
+              <a:buClr>
+                <a:srgbClr val="9F3434"/>
+              </a:buClr>
+              <a:buNone/>
+            </a:pPr>
+            <a:r>
+              <a:rPr lang="tr-TR" dirty="0"/>
+              <a:t>Çalışmada </a:t>
+            </a:r>
+            <a:r>
+              <a:rPr lang="tr-TR" b="1" dirty="0"/>
+              <a:t>Beyin Tümörü MRI veri seti</a:t>
+            </a:r>
+            <a:r>
+              <a:rPr lang="tr-TR" dirty="0"/>
+              <a:t> kullanılmıştır.</a:t>
+            </a:r>
+          </a:p>
+          <a:p>
+            <a:pPr marL="36900" indent="0">
+              <a:lnSpc>
+                <a:spcPct val="90000"/>
+              </a:lnSpc>
+              <a:buClr>
+                <a:srgbClr val="9F3434"/>
+              </a:buClr>
+              <a:buNone/>
+            </a:pPr>
+            <a:r>
+              <a:rPr lang="tr-TR" dirty="0"/>
+              <a:t>Veri setinin özellikleri:</a:t>
+            </a:r>
+          </a:p>
+          <a:p>
+            <a:pPr>
+              <a:lnSpc>
+                <a:spcPct val="90000"/>
+              </a:lnSpc>
+              <a:buClr>
+                <a:srgbClr val="9F3434"/>
+              </a:buClr>
+            </a:pPr>
+            <a:r>
+              <a:rPr lang="tr-TR" dirty="0"/>
+              <a:t>Görüntü türü: MRI</a:t>
+            </a:r>
+          </a:p>
+          <a:p>
+            <a:pPr>
+              <a:lnSpc>
+                <a:spcPct val="90000"/>
+              </a:lnSpc>
+              <a:buClr>
+                <a:srgbClr val="9F3434"/>
+              </a:buClr>
+            </a:pPr>
+            <a:r>
+              <a:rPr lang="tr-TR" dirty="0"/>
+              <a:t>Görüntü formatı: Gri tonlamalı (grayscale)</a:t>
+            </a:r>
+          </a:p>
+          <a:p>
+            <a:pPr>
+              <a:lnSpc>
+                <a:spcPct val="90000"/>
+              </a:lnSpc>
+              <a:buClr>
+                <a:srgbClr val="9F3434"/>
+              </a:buClr>
+            </a:pPr>
+            <a:r>
+              <a:rPr lang="tr-TR" dirty="0"/>
+              <a:t>Sınıf sayısı: 4</a:t>
+            </a:r>
+          </a:p>
+          <a:p>
+            <a:pPr>
+              <a:lnSpc>
+                <a:spcPct val="90000"/>
+              </a:lnSpc>
+              <a:buClr>
+                <a:srgbClr val="9F3434"/>
+              </a:buClr>
+            </a:pPr>
+            <a:r>
+              <a:rPr lang="tr-TR" dirty="0"/>
+              <a:t>Eğitim ve test veri ayrımı uygulanmıştır. (test seti validation olarak kullanılmıştır)</a:t>
+            </a:r>
+          </a:p>
+          <a:p>
+            <a:pPr>
+              <a:lnSpc>
+                <a:spcPct val="90000"/>
+              </a:lnSpc>
+              <a:buClr>
+                <a:srgbClr val="9F3434"/>
+              </a:buClr>
+            </a:pPr>
+            <a:r>
+              <a:rPr lang="tr-TR" dirty="0"/>
+              <a:t>Görüntü Boyutu: Çeşitli görüntü boyutları bulunmaktadır. Hepsi 224x224 seviyesine indirilmiştir.</a:t>
+            </a:r>
+          </a:p>
+          <a:p>
+            <a:pPr>
+              <a:lnSpc>
+                <a:spcPct val="90000"/>
+              </a:lnSpc>
+              <a:buClr>
+                <a:srgbClr val="9F3434"/>
+              </a:buClr>
+            </a:pPr>
+            <a:endParaRPr lang="tr-TR" dirty="0"/>
+          </a:p>
+        </p:txBody>
+      </p:sp>
+      <p:pic>
+        <p:nvPicPr>
+          <p:cNvPr id="2055" name="Picture 2054">
+            <a:extLst>
+              <a:ext uri="{FF2B5EF4-FFF2-40B4-BE49-F238E27FC236}">
+                <a16:creationId xmlns:a16="http://schemas.microsoft.com/office/drawing/2014/main" id="{AD661026-DE64-47F1-9F88-0847B5FB3560}"/>
+              </a:ext>
+              <a:ext uri="{C183D7F6-B498-43B3-948B-1728B52AA6E4}">
+                <adec:decorative xmlns:adec="http://schemas.microsoft.com/office/drawing/2017/decorative" val="1"/>
+              </a:ext>
+            </a:extLst>
+          </p:cNvPr>
+          <p:cNvPicPr>
+            <a:picLocks noGrp="1" noRot="1" noChangeAspect="1" noMove="1" noResize="1" noEditPoints="1" noAdjustHandles="1" noChangeArrowheads="1" noChangeShapeType="1" noCrop="1"/>
+          </p:cNvPicPr>
+          <p:nvPr>
+            <p:extLst>
+              <p:ext uri="{386F3935-93C4-4BCD-93E2-E3B085C9AB24}">
+                <p16:designElem xmlns:p16="http://schemas.microsoft.com/office/powerpoint/2015/main" val="1"/>
+              </p:ext>
+            </p:extLst>
+          </p:nvPr>
+        </p:nvPicPr>
+        <p:blipFill>
+          <a:blip r:embed="rId3">
+            <a:extLst>
+              <a:ext uri="{28A0092B-C50C-407E-A947-70E740481C1C}">
+                <a14:useLocalDpi xmlns:a14="http://schemas.microsoft.com/office/drawing/2010/main" val="0"/>
+              </a:ext>
+            </a:extLst>
+          </a:blip>
+          <a:stretch>
+            <a:fillRect/>
+          </a:stretch>
+        </p:blipFill>
+        <p:spPr>
+          <a:xfrm>
+            <a:off x="6934200" y="1998132"/>
+            <a:ext cx="4333632" cy="3521077"/>
+          </a:xfrm>
+          <a:prstGeom prst="rect">
+            <a:avLst/>
+          </a:prstGeom>
+        </p:spPr>
+      </p:pic>
+      <p:pic>
+        <p:nvPicPr>
+          <p:cNvPr id="2050" name="Picture 2" descr="Classification of Brain Tumors from MRI Images Using a Convolutional Neural  Network">
+            <a:extLst>
+              <a:ext uri="{FF2B5EF4-FFF2-40B4-BE49-F238E27FC236}">
+                <a16:creationId xmlns:a16="http://schemas.microsoft.com/office/drawing/2014/main" id="{A7006EFD-1A74-B168-506E-D821493D45E8}"/>
+              </a:ext>
+            </a:extLst>
+          </p:cNvPr>
+          <p:cNvPicPr>
+            <a:picLocks noChangeAspect="1" noChangeArrowheads="1"/>
+          </p:cNvPicPr>
+          <p:nvPr/>
+        </p:nvPicPr>
+        <p:blipFill>
+          <a:blip r:embed="rId4">
+            <a:extLst>
+              <a:ext uri="{28A0092B-C50C-407E-A947-70E740481C1C}">
+                <a14:useLocalDpi xmlns:a14="http://schemas.microsoft.com/office/drawing/2010/main" val="0"/>
+              </a:ext>
+            </a:extLst>
+          </a:blip>
+          <a:srcRect r="3" b="452"/>
+          <a:stretch>
+            <a:fillRect/>
+          </a:stretch>
+        </p:blipFill>
+        <p:spPr bwMode="auto">
+          <a:xfrm>
+            <a:off x="7066560" y="2132822"/>
+            <a:ext cx="4065464" cy="3258006"/>
+          </a:xfrm>
+          <a:prstGeom prst="rect">
+            <a:avLst/>
+          </a:prstGeom>
+          <a:noFill/>
+          <a:extLst>
+            <a:ext uri="{909E8E84-426E-40DD-AFC4-6F175D3DCCD1}">
+              <a14:hiddenFill xmlns:a14="http://schemas.microsoft.com/office/drawing/2010/main">
+                <a:solidFill>
+                  <a:srgbClr val="FFFFFF"/>
+                </a:solidFill>
+              </a14:hiddenFill>
+            </a:ext>
+          </a:extLst>
+        </p:spPr>
+      </p:pic>
+    </p:spTree>
+    <p:extLst>
+      <p:ext uri="{BB962C8B-B14F-4D97-AF65-F5344CB8AC3E}">
+        <p14:creationId xmlns:p14="http://schemas.microsoft.com/office/powerpoint/2010/main" val="1052238893"/>
+      </p:ext>
+    </p:extLst>
+  </p:cSld>
+  <p:clrMapOvr>
+    <a:masterClrMapping/>
+  </p:clrMapOvr>
+</p:sld>
+</file>
+
+<file path=ppt/slides/slide5.xml><?xml version="1.0" encoding="utf-8"?>
+<p:sld xmlns:a="http://schemas.openxmlformats.org/drawingml/2006/main" xmlns:r="http://schemas.openxmlformats.org/officeDocument/2006/relationships" xmlns:p="http://schemas.openxmlformats.org/presentationml/2006/main">
+  <p:cSld>
+    <p:spTree>
+      <p:nvGrpSpPr>
+        <p:cNvPr id="1" name=""/>
+        <p:cNvGrpSpPr/>
+        <p:nvPr/>
+      </p:nvGrpSpPr>
+      <p:grpSpPr>
+        <a:xfrm>
+          <a:off x="0" y="0"/>
+          <a:ext cx="0" cy="0"/>
+          <a:chOff x="0" y="0"/>
+          <a:chExt cx="0" cy="0"/>
+        </a:xfrm>
+      </p:grpSpPr>
+      <p:sp>
+        <p:nvSpPr>
+          <p:cNvPr id="2" name="Title 1">
+            <a:extLst>
+              <a:ext uri="{FF2B5EF4-FFF2-40B4-BE49-F238E27FC236}">
+                <a16:creationId xmlns:a16="http://schemas.microsoft.com/office/drawing/2014/main" id="{A209B079-887A-AA55-7717-838A39E1E24F}"/>
+              </a:ext>
+            </a:extLst>
+          </p:cNvPr>
+          <p:cNvSpPr>
+            <a:spLocks noGrp="1"/>
+          </p:cNvSpPr>
+          <p:nvPr>
+            <p:ph type="title"/>
+          </p:nvPr>
+        </p:nvSpPr>
+        <p:spPr>
+          <a:xfrm>
+            <a:off x="919119" y="173373"/>
+            <a:ext cx="10353762" cy="970450"/>
+          </a:xfrm>
+        </p:spPr>
+        <p:txBody>
+          <a:bodyPr>
+            <a:normAutofit/>
+          </a:bodyPr>
+          <a:lstStyle/>
+          <a:p>
+            <a:r>
+              <a:rPr lang="tr-TR" dirty="0"/>
+              <a:t>4. Kullanılan CNN Modelleri</a:t>
+            </a:r>
+          </a:p>
+        </p:txBody>
+      </p:sp>
+      <p:pic>
+        <p:nvPicPr>
+          <p:cNvPr id="5" name="Picture 4">
+            <a:extLst>
+              <a:ext uri="{FF2B5EF4-FFF2-40B4-BE49-F238E27FC236}">
+                <a16:creationId xmlns:a16="http://schemas.microsoft.com/office/drawing/2014/main" id="{A2D2E5FE-EAE4-B004-166C-31723A28DC3B}"/>
+              </a:ext>
+            </a:extLst>
+          </p:cNvPr>
+          <p:cNvPicPr>
+            <a:picLocks noChangeAspect="1"/>
+          </p:cNvPicPr>
+          <p:nvPr/>
+        </p:nvPicPr>
+        <p:blipFill>
+          <a:blip r:embed="rId2">
+            <a:extLst>
+              <a:ext uri="{28A0092B-C50C-407E-A947-70E740481C1C}">
+                <a14:useLocalDpi xmlns:a14="http://schemas.microsoft.com/office/drawing/2010/main" val="0"/>
+              </a:ext>
+            </a:extLst>
+          </a:blip>
+          <a:stretch>
+            <a:fillRect/>
+          </a:stretch>
+        </p:blipFill>
+        <p:spPr>
+          <a:xfrm>
+            <a:off x="0" y="1160601"/>
+            <a:ext cx="12192000" cy="5697399"/>
+          </a:xfrm>
+          <a:prstGeom prst="rect">
+            <a:avLst/>
+          </a:prstGeom>
+        </p:spPr>
+      </p:pic>
+    </p:spTree>
+    <p:extLst>
+      <p:ext uri="{BB962C8B-B14F-4D97-AF65-F5344CB8AC3E}">
+        <p14:creationId xmlns:p14="http://schemas.microsoft.com/office/powerpoint/2010/main" val="1256093078"/>
+      </p:ext>
+    </p:extLst>
+  </p:cSld>
+  <p:clrMapOvr>
+    <a:masterClrMapping/>
+  </p:clrMapOvr>
+</p:sld>
+</file>
+
+<file path=ppt/slides/slide6.xml><?xml version="1.0" encoding="utf-8"?>
+<p:sld xmlns:a="http://schemas.openxmlformats.org/drawingml/2006/main" xmlns:r="http://schemas.openxmlformats.org/officeDocument/2006/relationships" xmlns:p="http://schemas.openxmlformats.org/presentationml/2006/main">
+  <p:cSld>
+    <p:spTree>
+      <p:nvGrpSpPr>
+        <p:cNvPr id="1" name=""/>
+        <p:cNvGrpSpPr/>
+        <p:nvPr/>
+      </p:nvGrpSpPr>
+      <p:grpSpPr>
+        <a:xfrm>
+          <a:off x="0" y="0"/>
+          <a:ext cx="0" cy="0"/>
+          <a:chOff x="0" y="0"/>
+          <a:chExt cx="0" cy="0"/>
+        </a:xfrm>
+      </p:grpSpPr>
+      <p:sp>
+        <p:nvSpPr>
+          <p:cNvPr id="2" name="Title 1">
+            <a:extLst>
+              <a:ext uri="{FF2B5EF4-FFF2-40B4-BE49-F238E27FC236}">
+                <a16:creationId xmlns:a16="http://schemas.microsoft.com/office/drawing/2014/main" id="{EB59BE22-9BA6-55B4-D0CD-5079504DBDCC}"/>
+              </a:ext>
+            </a:extLst>
+          </p:cNvPr>
+          <p:cNvSpPr>
+            <a:spLocks noGrp="1"/>
+          </p:cNvSpPr>
+          <p:nvPr>
+            <p:ph type="title"/>
+          </p:nvPr>
+        </p:nvSpPr>
+        <p:spPr/>
+        <p:txBody>
+          <a:bodyPr/>
+          <a:lstStyle/>
+          <a:p>
+            <a:r>
+              <a:rPr lang="tr-TR" dirty="0"/>
+              <a:t>5. Deneysel Kurulum</a:t>
+            </a:r>
+          </a:p>
+        </p:txBody>
+      </p:sp>
+      <p:sp>
+        <p:nvSpPr>
+          <p:cNvPr id="3" name="Content Placeholder 2">
+            <a:extLst>
+              <a:ext uri="{FF2B5EF4-FFF2-40B4-BE49-F238E27FC236}">
+                <a16:creationId xmlns:a16="http://schemas.microsoft.com/office/drawing/2014/main" id="{51678F65-833A-8AC1-DD3B-5202311A8806}"/>
+              </a:ext>
+            </a:extLst>
+          </p:cNvPr>
+          <p:cNvSpPr>
+            <a:spLocks noGrp="1"/>
+          </p:cNvSpPr>
+          <p:nvPr>
+            <p:ph idx="1"/>
+          </p:nvPr>
+        </p:nvSpPr>
+        <p:spPr/>
+        <p:txBody>
+          <a:bodyPr/>
+          <a:lstStyle/>
+          <a:p>
+            <a:pPr marL="36900" indent="0">
+              <a:buNone/>
+            </a:pPr>
+            <a:r>
+              <a:rPr lang="tr-TR" dirty="0"/>
+              <a:t>Eğitim sürecinde kullanılan temel parametreler:</a:t>
+            </a:r>
+          </a:p>
+          <a:p>
+            <a:r>
+              <a:rPr lang="tr-TR" dirty="0"/>
+              <a:t>Epoch sayısı: 200</a:t>
+            </a:r>
+          </a:p>
+          <a:p>
+            <a:r>
+              <a:rPr lang="tr-TR" dirty="0"/>
+              <a:t>Batch size: 32</a:t>
+            </a:r>
+          </a:p>
+          <a:p>
+            <a:r>
+              <a:rPr lang="tr-TR" dirty="0"/>
+              <a:t>Optimizer: Adam</a:t>
+            </a:r>
+          </a:p>
+          <a:p>
+            <a:r>
+              <a:rPr lang="tr-TR" dirty="0"/>
+              <a:t>Loss fonksiyonu: Cross Entropy</a:t>
+            </a:r>
+          </a:p>
+          <a:p>
+            <a:r>
+              <a:rPr lang="tr-TR" dirty="0"/>
+              <a:t>Her epoch sonunda modellerin </a:t>
+            </a:r>
+            <a:r>
+              <a:rPr lang="tr-TR" b="1" dirty="0"/>
+              <a:t>loss değerleri hesaplanmıştır.</a:t>
+            </a:r>
+          </a:p>
+          <a:p>
+            <a:r>
+              <a:rPr lang="tr-TR" dirty="0"/>
+              <a:t>Early stopping: 7 Epoch patience – validation loss’a göre</a:t>
+            </a:r>
+          </a:p>
+          <a:p>
+            <a:r>
+              <a:rPr lang="tr-TR" dirty="0"/>
+              <a:t>Reduce LR On Plateu: 4 Epoch patience – validation loss’a göre</a:t>
+            </a:r>
+          </a:p>
+          <a:p>
+            <a:r>
+              <a:rPr lang="tr-TR" dirty="0"/>
+              <a:t>Özel şart: Modeller en az 50 epoch eğitilmiştir.</a:t>
+            </a:r>
+          </a:p>
+          <a:p>
+            <a:endParaRPr lang="tr-TR" dirty="0"/>
+          </a:p>
+        </p:txBody>
+      </p:sp>
+    </p:spTree>
+    <p:extLst>
+      <p:ext uri="{BB962C8B-B14F-4D97-AF65-F5344CB8AC3E}">
+        <p14:creationId xmlns:p14="http://schemas.microsoft.com/office/powerpoint/2010/main" val="219534034"/>
+      </p:ext>
+    </p:extLst>
+  </p:cSld>
+  <p:clrMapOvr>
+    <a:masterClrMapping/>
+  </p:clrMapOvr>
+</p:sld>
+</file>
+
+<file path=ppt/slides/slide7.xml><?xml version="1.0" encoding="utf-8"?>
+<p:sld xmlns:a="http://schemas.openxmlformats.org/drawingml/2006/main" xmlns:r="http://schemas.openxmlformats.org/officeDocument/2006/relationships" xmlns:p="http://schemas.openxmlformats.org/presentationml/2006/main">
+  <p:cSld>
+    <p:spTree>
+      <p:nvGrpSpPr>
+        <p:cNvPr id="1" name=""/>
+        <p:cNvGrpSpPr/>
+        <p:nvPr/>
+      </p:nvGrpSpPr>
+      <p:grpSpPr>
+        <a:xfrm>
+          <a:off x="0" y="0"/>
+          <a:ext cx="0" cy="0"/>
+          <a:chOff x="0" y="0"/>
+          <a:chExt cx="0" cy="0"/>
+        </a:xfrm>
+      </p:grpSpPr>
+      <p:sp>
+        <p:nvSpPr>
+          <p:cNvPr id="2" name="Title 1">
+            <a:extLst>
+              <a:ext uri="{FF2B5EF4-FFF2-40B4-BE49-F238E27FC236}">
+                <a16:creationId xmlns:a16="http://schemas.microsoft.com/office/drawing/2014/main" id="{59CC0BFA-FF69-57B8-0D5E-36905D9BA790}"/>
+              </a:ext>
+            </a:extLst>
+          </p:cNvPr>
+          <p:cNvSpPr>
+            <a:spLocks noGrp="1"/>
+          </p:cNvSpPr>
+          <p:nvPr>
+            <p:ph type="title"/>
+          </p:nvPr>
+        </p:nvSpPr>
+        <p:spPr/>
+        <p:txBody>
+          <a:bodyPr>
+            <a:normAutofit/>
+          </a:bodyPr>
+          <a:lstStyle/>
+          <a:p>
+            <a:r>
+              <a:rPr lang="tr-TR" dirty="0"/>
+              <a:t>6. Yöntem</a:t>
+            </a:r>
+          </a:p>
+        </p:txBody>
+      </p:sp>
+      <p:sp>
+        <p:nvSpPr>
+          <p:cNvPr id="3" name="Content Placeholder 2">
+            <a:extLst>
+              <a:ext uri="{FF2B5EF4-FFF2-40B4-BE49-F238E27FC236}">
+                <a16:creationId xmlns:a16="http://schemas.microsoft.com/office/drawing/2014/main" id="{4430690A-E569-116C-3361-E35776E1C851}"/>
+              </a:ext>
+            </a:extLst>
+          </p:cNvPr>
+          <p:cNvSpPr>
+            <a:spLocks noGrp="1"/>
+          </p:cNvSpPr>
+          <p:nvPr>
+            <p:ph idx="1"/>
+          </p:nvPr>
+        </p:nvSpPr>
+        <p:spPr/>
+        <p:txBody>
+          <a:bodyPr/>
+          <a:lstStyle/>
+          <a:p>
+            <a:pPr marL="36900" indent="0">
+              <a:buNone/>
+            </a:pPr>
+            <a:r>
+              <a:rPr lang="tr-TR" dirty="0"/>
+              <a:t>Çalışmanın yöntemi aşağıdaki adımlardan oluşmaktadır:</a:t>
+            </a:r>
+          </a:p>
+          <a:p>
+            <a:r>
+              <a:rPr lang="tr-TR" dirty="0"/>
+              <a:t>Her model için tüm epochlarda elde edilen validation loss değerlerinin en düşüğü, modelin en başarılı hali olarak kabul edilmiştir. (Çünkü eğitime devam edilmesi modelin başarısını düşürebilir.)</a:t>
+            </a:r>
+          </a:p>
+          <a:p>
+            <a:r>
+              <a:rPr lang="tr-TR" dirty="0"/>
+              <a:t>Tüm modellerin en iyi durumları belirlenerek performans sıralaması oluşturulmuştur.</a:t>
+            </a:r>
+          </a:p>
+          <a:p>
+            <a:r>
+              <a:rPr lang="tr-TR" dirty="0"/>
+              <a:t>Ara epochlardaki sıralamalar ile bu “en iyi sıralama” Spearman korelasyonu kullanılarak karşılaştırılmıştır.</a:t>
+            </a:r>
+          </a:p>
+          <a:p>
+            <a:pPr lvl="1"/>
+            <a:r>
+              <a:rPr lang="tr-TR" dirty="0"/>
+              <a:t>Hem tüm modellerin sıralamaları</a:t>
+            </a:r>
+          </a:p>
+          <a:p>
+            <a:pPr lvl="1"/>
+            <a:r>
+              <a:rPr lang="tr-TR" dirty="0"/>
+              <a:t>Hem de sadece en iyi 3 modelin sıralamaları için ayrı analiz yapılmıştır</a:t>
+            </a:r>
+          </a:p>
+        </p:txBody>
+      </p:sp>
+    </p:spTree>
+    <p:extLst>
+      <p:ext uri="{BB962C8B-B14F-4D97-AF65-F5344CB8AC3E}">
+        <p14:creationId xmlns:p14="http://schemas.microsoft.com/office/powerpoint/2010/main" val="2109377488"/>
+      </p:ext>
+    </p:extLst>
+  </p:cSld>
+  <p:clrMapOvr>
+    <a:masterClrMapping/>
+  </p:clrMapOvr>
+</p:sld>
+</file>
+
+<file path=ppt/slides/slide8.xml><?xml version="1.0" encoding="utf-8"?>
+<p:sld xmlns:a="http://schemas.openxmlformats.org/drawingml/2006/main" xmlns:r="http://schemas.openxmlformats.org/officeDocument/2006/relationships" xmlns:p="http://schemas.openxmlformats.org/presentationml/2006/main">
+  <p:cSld>
+    <p:spTree>
+      <p:nvGrpSpPr>
+        <p:cNvPr id="1" name=""/>
+        <p:cNvGrpSpPr/>
+        <p:nvPr/>
+      </p:nvGrpSpPr>
+      <p:grpSpPr>
+        <a:xfrm>
+          <a:off x="0" y="0"/>
+          <a:ext cx="0" cy="0"/>
+          <a:chOff x="0" y="0"/>
+          <a:chExt cx="0" cy="0"/>
+        </a:xfrm>
+      </p:grpSpPr>
+      <p:sp>
+        <p:nvSpPr>
+          <p:cNvPr id="2" name="Title 1">
+            <a:extLst>
+              <a:ext uri="{FF2B5EF4-FFF2-40B4-BE49-F238E27FC236}">
+                <a16:creationId xmlns:a16="http://schemas.microsoft.com/office/drawing/2014/main" id="{4E27D7EA-9883-0124-13CD-0E1C57A0F35A}"/>
+              </a:ext>
+            </a:extLst>
+          </p:cNvPr>
+          <p:cNvSpPr>
+            <a:spLocks noGrp="1"/>
+          </p:cNvSpPr>
+          <p:nvPr>
+            <p:ph type="title"/>
+          </p:nvPr>
+        </p:nvSpPr>
+        <p:spPr/>
+        <p:txBody>
+          <a:bodyPr/>
+          <a:lstStyle/>
+          <a:p>
+            <a:r>
+              <a:rPr lang="tr-TR" dirty="0"/>
+              <a:t>7. Sıralama Analizi</a:t>
+            </a:r>
+          </a:p>
+        </p:txBody>
+      </p:sp>
+      <p:sp>
+        <p:nvSpPr>
+          <p:cNvPr id="3" name="Content Placeholder 2">
+            <a:extLst>
+              <a:ext uri="{FF2B5EF4-FFF2-40B4-BE49-F238E27FC236}">
+                <a16:creationId xmlns:a16="http://schemas.microsoft.com/office/drawing/2014/main" id="{5C3EBAA2-55A6-E86A-BF2B-A3AAEA6E1D22}"/>
+              </a:ext>
+            </a:extLst>
+          </p:cNvPr>
+          <p:cNvSpPr>
+            <a:spLocks noGrp="1"/>
+          </p:cNvSpPr>
+          <p:nvPr>
+            <p:ph idx="1"/>
+          </p:nvPr>
+        </p:nvSpPr>
+        <p:spPr/>
+        <p:txBody>
+          <a:bodyPr/>
+          <a:lstStyle/>
+          <a:p>
+            <a:pPr marL="36900" indent="0">
+              <a:buNone/>
+            </a:pPr>
+            <a:r>
+              <a:rPr lang="tr-TR" dirty="0"/>
+              <a:t>Analiz aşamasında şunlar incelenmiştir:</a:t>
+            </a:r>
+          </a:p>
+          <a:p>
+            <a:r>
+              <a:rPr lang="tr-TR" dirty="0"/>
+              <a:t>Her epoch için </a:t>
+            </a:r>
+            <a:r>
+              <a:rPr lang="tr-TR" b="1" dirty="0"/>
+              <a:t>model sıralamasının en iyi sıralama ile korelasyonu</a:t>
+            </a:r>
+            <a:r>
+              <a:rPr lang="tr-TR" dirty="0"/>
+              <a:t> hesaplanmıştır.</a:t>
+            </a:r>
+          </a:p>
+          <a:p>
+            <a:r>
+              <a:rPr lang="tr-TR" b="1" dirty="0"/>
+              <a:t>Tüm modeller</a:t>
+            </a:r>
+            <a:r>
+              <a:rPr lang="tr-TR" dirty="0"/>
+              <a:t> ve </a:t>
+            </a:r>
+            <a:r>
+              <a:rPr lang="tr-TR" b="1" dirty="0"/>
+              <a:t>en iyi 3 model</a:t>
+            </a:r>
+            <a:r>
+              <a:rPr lang="tr-TR" dirty="0"/>
+              <a:t> için ayrı ayrı değerlendirme yapılmıştır.</a:t>
+            </a:r>
+          </a:p>
+          <a:p>
+            <a:r>
+              <a:rPr lang="tr-TR" dirty="0"/>
+              <a:t>Amaç: Model sıralamasının </a:t>
+            </a:r>
+            <a:r>
+              <a:rPr lang="tr-TR" b="1" dirty="0"/>
+              <a:t>hangi epoch’tan itibaren stabil hale geldiğini</a:t>
+            </a:r>
+            <a:r>
+              <a:rPr lang="tr-TR" dirty="0"/>
+              <a:t> belirlemek.</a:t>
+            </a:r>
+          </a:p>
+        </p:txBody>
+      </p:sp>
+    </p:spTree>
+    <p:extLst>
+      <p:ext uri="{BB962C8B-B14F-4D97-AF65-F5344CB8AC3E}">
+        <p14:creationId xmlns:p14="http://schemas.microsoft.com/office/powerpoint/2010/main" val="1871995477"/>
+      </p:ext>
+    </p:extLst>
+  </p:cSld>
+  <p:clrMapOvr>
+    <a:masterClrMapping/>
+  </p:clrMapOvr>
+</p:sld>
+</file>
+
+<file path=ppt/slides/slide9.xml><?xml version="1.0" encoding="utf-8"?>
+<p:sld xmlns:a="http://schemas.openxmlformats.org/drawingml/2006/main" xmlns:r="http://schemas.openxmlformats.org/officeDocument/2006/relationships" xmlns:p="http://schemas.openxmlformats.org/presentationml/2006/main">
+  <p:cSld>
+    <p:bg>
+      <p:bgPr>
+        <a:blipFill rotWithShape="1">
+          <a:blip r:embed="rId2">
+            <a:duotone>
+              <a:schemeClr val="bg2">
+                <a:shade val="80000"/>
+                <a:lumMod val="80000"/>
+              </a:schemeClr>
+              <a:schemeClr val="bg2">
+                <a:tint val="98000"/>
+              </a:schemeClr>
+            </a:duotone>
+          </a:blip>
+          <a:stretch/>
+        </a:blipFill>
+        <a:effectLst/>
+      </p:bgPr>
+    </p:bg>
+    <p:spTree>
+      <p:nvGrpSpPr>
+        <p:cNvPr id="1" name=""/>
+        <p:cNvGrpSpPr/>
+        <p:nvPr/>
+      </p:nvGrpSpPr>
+      <p:grpSpPr>
+        <a:xfrm>
+          <a:off x="0" y="0"/>
+          <a:ext cx="0" cy="0"/>
+          <a:chOff x="0" y="0"/>
+          <a:chExt cx="0" cy="0"/>
+        </a:xfrm>
+      </p:grpSpPr>
+      <p:sp>
+        <p:nvSpPr>
+          <p:cNvPr id="2" name="Title 1">
+            <a:extLst>
+              <a:ext uri="{FF2B5EF4-FFF2-40B4-BE49-F238E27FC236}">
+                <a16:creationId xmlns:a16="http://schemas.microsoft.com/office/drawing/2014/main" id="{DF210141-8982-84AB-8F20-C08AF3A5B298}"/>
+              </a:ext>
+            </a:extLst>
+          </p:cNvPr>
+          <p:cNvSpPr>
+            <a:spLocks noGrp="1"/>
+          </p:cNvSpPr>
+          <p:nvPr>
+            <p:ph type="title"/>
+          </p:nvPr>
+        </p:nvSpPr>
+        <p:spPr>
+          <a:xfrm>
+            <a:off x="1370693" y="4511814"/>
+            <a:ext cx="9440034" cy="1130260"/>
+          </a:xfrm>
+        </p:spPr>
+        <p:txBody>
+          <a:bodyPr vert="horz" lIns="91440" tIns="45720" rIns="91440" bIns="45720" rtlCol="0" anchor="b">
+            <a:normAutofit/>
+          </a:bodyPr>
+          <a:lstStyle/>
+          <a:p>
+            <a:r>
+              <a:rPr lang="en-US" sz="4800" dirty="0"/>
+              <a:t>8. Deney </a:t>
+            </a:r>
+            <a:r>
+              <a:rPr lang="en-US" sz="4800" dirty="0" err="1"/>
+              <a:t>Sonuçları</a:t>
+            </a:r>
+            <a:endParaRPr lang="en-US" sz="4800" dirty="0"/>
+          </a:p>
+        </p:txBody>
+      </p:sp>
+      <p:pic>
+        <p:nvPicPr>
+          <p:cNvPr id="27" name="Picture 26">
+            <a:extLst>
+              <a:ext uri="{FF2B5EF4-FFF2-40B4-BE49-F238E27FC236}">
+                <a16:creationId xmlns:a16="http://schemas.microsoft.com/office/drawing/2014/main" id="{D04C0182-96E7-4A1B-8EAB-F910C2F3ED48}"/>
+              </a:ext>
+              <a:ext uri="{C183D7F6-B498-43B3-948B-1728B52AA6E4}">
+                <adec:decorative xmlns:adec="http://schemas.microsoft.com/office/drawing/2017/decorative" val="1"/>
+              </a:ext>
+            </a:extLst>
+          </p:cNvPr>
+          <p:cNvPicPr>
+            <a:picLocks noGrp="1" noRot="1" noChangeAspect="1" noMove="1" noResize="1" noEditPoints="1" noAdjustHandles="1" noChangeArrowheads="1" noChangeShapeType="1" noCrop="1"/>
+          </p:cNvPicPr>
+          <p:nvPr>
+            <p:extLst>
+              <p:ext uri="{386F3935-93C4-4BCD-93E2-E3B085C9AB24}">
+                <p16:designElem xmlns:p16="http://schemas.microsoft.com/office/powerpoint/2015/main" val="1"/>
+              </p:ext>
+            </p:extLst>
+          </p:nvPr>
+        </p:nvPicPr>
+        <p:blipFill>
+          <a:blip r:embed="rId3">
+            <a:extLst>
+              <a:ext uri="{28A0092B-C50C-407E-A947-70E740481C1C}">
+                <a14:useLocalDpi xmlns:a14="http://schemas.microsoft.com/office/drawing/2010/main" val="0"/>
+              </a:ext>
+            </a:extLst>
+          </a:blip>
+          <a:stretch>
+            <a:fillRect/>
+          </a:stretch>
+        </p:blipFill>
+        <p:spPr>
+          <a:xfrm>
+            <a:off x="628022" y="547807"/>
+            <a:ext cx="10935956" cy="3816806"/>
+          </a:xfrm>
+          <a:prstGeom prst="rect">
+            <a:avLst/>
+          </a:prstGeom>
+        </p:spPr>
+      </p:pic>
+      <p:pic>
+        <p:nvPicPr>
+          <p:cNvPr id="22" name="Picture 21">
+            <a:extLst>
+              <a:ext uri="{FF2B5EF4-FFF2-40B4-BE49-F238E27FC236}">
+                <a16:creationId xmlns:a16="http://schemas.microsoft.com/office/drawing/2014/main" id="{8AF7B9AA-D5D8-9614-5660-7E5FBAD5E9C0}"/>
+              </a:ext>
+            </a:extLst>
+          </p:cNvPr>
+          <p:cNvPicPr>
+            <a:picLocks noChangeAspect="1"/>
+          </p:cNvPicPr>
+          <p:nvPr/>
+        </p:nvPicPr>
+        <p:blipFill>
+          <a:blip r:embed="rId4">
+            <a:extLst>
+              <a:ext uri="{28A0092B-C50C-407E-A947-70E740481C1C}">
+                <a14:useLocalDpi xmlns:a14="http://schemas.microsoft.com/office/drawing/2010/main" val="0"/>
+              </a:ext>
+            </a:extLst>
+          </a:blip>
+          <a:stretch>
+            <a:fillRect/>
+          </a:stretch>
+        </p:blipFill>
+        <p:spPr>
+          <a:xfrm>
+            <a:off x="1318380" y="839047"/>
+            <a:ext cx="4292600" cy="3219450"/>
+          </a:xfrm>
+          <a:prstGeom prst="rect">
+            <a:avLst/>
+          </a:prstGeom>
+        </p:spPr>
+      </p:pic>
+      <p:pic>
+        <p:nvPicPr>
+          <p:cNvPr id="19" name="Picture 18">
+            <a:extLst>
+              <a:ext uri="{FF2B5EF4-FFF2-40B4-BE49-F238E27FC236}">
+                <a16:creationId xmlns:a16="http://schemas.microsoft.com/office/drawing/2014/main" id="{E23EDF2F-83A4-BEBE-1044-AE4016F44256}"/>
+              </a:ext>
+            </a:extLst>
+          </p:cNvPr>
+          <p:cNvPicPr>
+            <a:picLocks noChangeAspect="1"/>
+          </p:cNvPicPr>
+          <p:nvPr/>
+        </p:nvPicPr>
+        <p:blipFill>
+          <a:blip r:embed="rId5">
+            <a:extLst>
+              <a:ext uri="{28A0092B-C50C-407E-A947-70E740481C1C}">
+                <a14:useLocalDpi xmlns:a14="http://schemas.microsoft.com/office/drawing/2010/main" val="0"/>
+              </a:ext>
+            </a:extLst>
+          </a:blip>
+          <a:stretch>
+            <a:fillRect/>
+          </a:stretch>
+        </p:blipFill>
+        <p:spPr>
+          <a:xfrm>
+            <a:off x="6575697" y="839047"/>
+            <a:ext cx="4292600" cy="3219450"/>
+          </a:xfrm>
+          <a:prstGeom prst="rect">
+            <a:avLst/>
+          </a:prstGeom>
+        </p:spPr>
+      </p:pic>
+    </p:spTree>
+    <p:extLst>
+      <p:ext uri="{BB962C8B-B14F-4D97-AF65-F5344CB8AC3E}">
+        <p14:creationId xmlns:p14="http://schemas.microsoft.com/office/powerpoint/2010/main" val="267456535"/>
       </p:ext>
     </p:extLst>
   </p:cSld>

</xml_diff>

<commit_message>
Derive final ranking from histories; top3 overlap
Stop depending on results_ranked.json and instead compute the final ranking directly from model histories (min val per model). Replace the previous Spearman-based "correlation_top3" with a simpler top-3 overlap fraction and propagate that change through CSV, JSON, plotting and table-generation logic. Rename outputs (epoch_similarity.json -> epoch_analyzes.json, correlation_all.png -> correlation.png) and adjust defaults to avoid creating many intermediate files (skip writing results_ranked.json/epoch_rankings.json/epoch_rank_names_table.csv by default). Improve save_rank_names_table to accept final stats, produce a main epochs table image and a separate final-ranking image, and make small visual tweaks to the tables and plots. Remove obsolete files and update example result JSON accordingly.
</commit_message>
<xml_diff>
--- a/other/sunum.pptx
+++ b/other/sunum.pptx
@@ -15,7 +15,8 @@
     <p:sldId id="264" r:id="rId9"/>
     <p:sldId id="265" r:id="rId10"/>
     <p:sldId id="266" r:id="rId11"/>
-    <p:sldId id="261" r:id="rId12"/>
+    <p:sldId id="267" r:id="rId12"/>
+    <p:sldId id="261" r:id="rId13"/>
   </p:sldIdLst>
   <p:sldSz cx="12192000" cy="6858000"/>
   <p:notesSz cx="6858000" cy="9144000"/>
@@ -307,7 +308,7 @@
           <a:p>
             <a:fld id="{3E0254F8-EA1E-4190-9E7C-C0EBFFD65A44}" type="datetimeFigureOut">
               <a:rPr lang="tr-TR" smtClean="0"/>
-              <a:t>11.03.2026</a:t>
+              <a:t>13.03.2026</a:t>
             </a:fld>
             <a:endParaRPr lang="tr-TR"/>
           </a:p>
@@ -605,7 +606,7 @@
           <a:p>
             <a:fld id="{3E0254F8-EA1E-4190-9E7C-C0EBFFD65A44}" type="datetimeFigureOut">
               <a:rPr lang="tr-TR" smtClean="0"/>
-              <a:t>11.03.2026</a:t>
+              <a:t>13.03.2026</a:t>
             </a:fld>
             <a:endParaRPr lang="tr-TR"/>
           </a:p>
@@ -797,7 +798,7 @@
           <a:p>
             <a:fld id="{3E0254F8-EA1E-4190-9E7C-C0EBFFD65A44}" type="datetimeFigureOut">
               <a:rPr lang="tr-TR" smtClean="0"/>
-              <a:t>11.03.2026</a:t>
+              <a:t>13.03.2026</a:t>
             </a:fld>
             <a:endParaRPr lang="tr-TR"/>
           </a:p>
@@ -1058,7 +1059,7 @@
           <a:p>
             <a:fld id="{3E0254F8-EA1E-4190-9E7C-C0EBFFD65A44}" type="datetimeFigureOut">
               <a:rPr lang="tr-TR" smtClean="0"/>
-              <a:t>11.03.2026</a:t>
+              <a:t>13.03.2026</a:t>
             </a:fld>
             <a:endParaRPr lang="tr-TR"/>
           </a:p>
@@ -1482,7 +1483,7 @@
           <a:p>
             <a:fld id="{3E0254F8-EA1E-4190-9E7C-C0EBFFD65A44}" type="datetimeFigureOut">
               <a:rPr lang="tr-TR" smtClean="0"/>
-              <a:t>11.03.2026</a:t>
+              <a:t>13.03.2026</a:t>
             </a:fld>
             <a:endParaRPr lang="tr-TR"/>
           </a:p>
@@ -2019,7 +2020,7 @@
           <a:p>
             <a:fld id="{3E0254F8-EA1E-4190-9E7C-C0EBFFD65A44}" type="datetimeFigureOut">
               <a:rPr lang="tr-TR" smtClean="0"/>
-              <a:t>11.03.2026</a:t>
+              <a:t>13.03.2026</a:t>
             </a:fld>
             <a:endParaRPr lang="tr-TR"/>
           </a:p>
@@ -2883,7 +2884,7 @@
           <a:p>
             <a:fld id="{3E0254F8-EA1E-4190-9E7C-C0EBFFD65A44}" type="datetimeFigureOut">
               <a:rPr lang="tr-TR" smtClean="0"/>
-              <a:t>11.03.2026</a:t>
+              <a:t>13.03.2026</a:t>
             </a:fld>
             <a:endParaRPr lang="tr-TR"/>
           </a:p>
@@ -3053,7 +3054,7 @@
           <a:p>
             <a:fld id="{3E0254F8-EA1E-4190-9E7C-C0EBFFD65A44}" type="datetimeFigureOut">
               <a:rPr lang="tr-TR" smtClean="0"/>
-              <a:t>11.03.2026</a:t>
+              <a:t>13.03.2026</a:t>
             </a:fld>
             <a:endParaRPr lang="tr-TR"/>
           </a:p>
@@ -3237,7 +3238,7 @@
           <a:p>
             <a:fld id="{3E0254F8-EA1E-4190-9E7C-C0EBFFD65A44}" type="datetimeFigureOut">
               <a:rPr lang="tr-TR" smtClean="0"/>
-              <a:t>11.03.2026</a:t>
+              <a:t>13.03.2026</a:t>
             </a:fld>
             <a:endParaRPr lang="tr-TR"/>
           </a:p>
@@ -3407,7 +3408,7 @@
           <a:p>
             <a:fld id="{3E0254F8-EA1E-4190-9E7C-C0EBFFD65A44}" type="datetimeFigureOut">
               <a:rPr lang="tr-TR" smtClean="0"/>
-              <a:t>11.03.2026</a:t>
+              <a:t>13.03.2026</a:t>
             </a:fld>
             <a:endParaRPr lang="tr-TR"/>
           </a:p>
@@ -3651,7 +3652,7 @@
           <a:p>
             <a:fld id="{3E0254F8-EA1E-4190-9E7C-C0EBFFD65A44}" type="datetimeFigureOut">
               <a:rPr lang="tr-TR" smtClean="0"/>
-              <a:t>11.03.2026</a:t>
+              <a:t>13.03.2026</a:t>
             </a:fld>
             <a:endParaRPr lang="tr-TR"/>
           </a:p>
@@ -3887,7 +3888,7 @@
           <a:p>
             <a:fld id="{3E0254F8-EA1E-4190-9E7C-C0EBFFD65A44}" type="datetimeFigureOut">
               <a:rPr lang="tr-TR" smtClean="0"/>
-              <a:t>11.03.2026</a:t>
+              <a:t>13.03.2026</a:t>
             </a:fld>
             <a:endParaRPr lang="tr-TR"/>
           </a:p>
@@ -4353,7 +4354,7 @@
           <a:p>
             <a:fld id="{3E0254F8-EA1E-4190-9E7C-C0EBFFD65A44}" type="datetimeFigureOut">
               <a:rPr lang="tr-TR" smtClean="0"/>
-              <a:t>11.03.2026</a:t>
+              <a:t>13.03.2026</a:t>
             </a:fld>
             <a:endParaRPr lang="tr-TR"/>
           </a:p>
@@ -4471,7 +4472,7 @@
           <a:p>
             <a:fld id="{3E0254F8-EA1E-4190-9E7C-C0EBFFD65A44}" type="datetimeFigureOut">
               <a:rPr lang="tr-TR" smtClean="0"/>
-              <a:t>11.03.2026</a:t>
+              <a:t>13.03.2026</a:t>
             </a:fld>
             <a:endParaRPr lang="tr-TR"/>
           </a:p>
@@ -4566,7 +4567,7 @@
           <a:p>
             <a:fld id="{3E0254F8-EA1E-4190-9E7C-C0EBFFD65A44}" type="datetimeFigureOut">
               <a:rPr lang="tr-TR" smtClean="0"/>
-              <a:t>11.03.2026</a:t>
+              <a:t>13.03.2026</a:t>
             </a:fld>
             <a:endParaRPr lang="tr-TR"/>
           </a:p>
@@ -4821,7 +4822,7 @@
           <a:p>
             <a:fld id="{3E0254F8-EA1E-4190-9E7C-C0EBFFD65A44}" type="datetimeFigureOut">
               <a:rPr lang="tr-TR" smtClean="0"/>
-              <a:t>11.03.2026</a:t>
+              <a:t>13.03.2026</a:t>
             </a:fld>
             <a:endParaRPr lang="tr-TR"/>
           </a:p>
@@ -5121,7 +5122,7 @@
           <a:p>
             <a:fld id="{3E0254F8-EA1E-4190-9E7C-C0EBFFD65A44}" type="datetimeFigureOut">
               <a:rPr lang="tr-TR" smtClean="0"/>
-              <a:t>11.03.2026</a:t>
+              <a:t>13.03.2026</a:t>
             </a:fld>
             <a:endParaRPr lang="tr-TR"/>
           </a:p>
@@ -5355,7 +5356,7 @@
           <a:p>
             <a:fld id="{3E0254F8-EA1E-4190-9E7C-C0EBFFD65A44}" type="datetimeFigureOut">
               <a:rPr lang="tr-TR" smtClean="0"/>
-              <a:t>11.03.2026</a:t>
+              <a:t>13.03.2026</a:t>
             </a:fld>
             <a:endParaRPr lang="tr-TR"/>
           </a:p>
@@ -6722,6 +6723,25 @@
 <file path=ppt/slides/slide10.xml><?xml version="1.0" encoding="utf-8"?>
 <p:sld xmlns:a="http://schemas.openxmlformats.org/drawingml/2006/main" xmlns:r="http://schemas.openxmlformats.org/officeDocument/2006/relationships" xmlns:p="http://schemas.openxmlformats.org/presentationml/2006/main">
   <p:cSld>
+    <p:bg>
+      <p:bgPr>
+        <a:blipFill rotWithShape="1">
+          <a:blip r:embed="rId2">
+            <a:duotone>
+              <a:schemeClr val="bg2">
+                <a:shade val="80000"/>
+                <a:lumMod val="80000"/>
+              </a:schemeClr>
+              <a:schemeClr val="bg2">
+                <a:tint val="98000"/>
+              </a:schemeClr>
+            </a:duotone>
+          </a:blip>
+          <a:stretch/>
+        </a:blipFill>
+        <a:effectLst/>
+      </p:bgPr>
+    </p:bg>
     <p:spTree>
       <p:nvGrpSpPr>
         <p:cNvPr id="1" name=""/>
@@ -6752,18 +6772,154 @@
             <p:ph type="title"/>
           </p:nvPr>
         </p:nvSpPr>
-        <p:spPr/>
-        <p:txBody>
-          <a:bodyPr/>
+        <p:spPr>
+          <a:xfrm>
+            <a:off x="1370693" y="4511814"/>
+            <a:ext cx="9440034" cy="1130260"/>
+          </a:xfrm>
+        </p:spPr>
+        <p:txBody>
+          <a:bodyPr vert="horz" lIns="91440" tIns="45720" rIns="91440" bIns="45720" rtlCol="0" anchor="b">
+            <a:normAutofit/>
+          </a:bodyPr>
           <a:lstStyle/>
           <a:p>
-            <a:r>
-              <a:rPr lang="tr-TR" dirty="0"/>
-              <a:t>9. Deney Sonuçları</a:t>
-            </a:r>
-          </a:p>
-        </p:txBody>
-      </p:sp>
+            <a:pPr>
+              <a:lnSpc>
+                <a:spcPct val="90000"/>
+              </a:lnSpc>
+            </a:pPr>
+            <a:r>
+              <a:rPr lang="en-US" sz="3700"/>
+              <a:t>9. Deney Sonuçları:</a:t>
+            </a:r>
+            <a:br>
+              <a:rPr lang="en-US" sz="3700"/>
+            </a:br>
+            <a:r>
+              <a:rPr lang="en-US" sz="3700"/>
+              <a:t>Korelasyon ve Overlap Grafikleri</a:t>
+            </a:r>
+          </a:p>
+        </p:txBody>
+      </p:sp>
+      <p:pic>
+        <p:nvPicPr>
+          <p:cNvPr id="16" name="Picture 15">
+            <a:extLst>
+              <a:ext uri="{FF2B5EF4-FFF2-40B4-BE49-F238E27FC236}">
+                <a16:creationId xmlns:a16="http://schemas.microsoft.com/office/drawing/2014/main" id="{D04C0182-96E7-4A1B-8EAB-F910C2F3ED48}"/>
+              </a:ext>
+              <a:ext uri="{C183D7F6-B498-43B3-948B-1728B52AA6E4}">
+                <adec:decorative xmlns:adec="http://schemas.microsoft.com/office/drawing/2017/decorative" val="1"/>
+              </a:ext>
+            </a:extLst>
+          </p:cNvPr>
+          <p:cNvPicPr>
+            <a:picLocks noGrp="1" noRot="1" noChangeAspect="1" noMove="1" noResize="1" noEditPoints="1" noAdjustHandles="1" noChangeArrowheads="1" noChangeShapeType="1" noCrop="1"/>
+          </p:cNvPicPr>
+          <p:nvPr>
+            <p:extLst>
+              <p:ext uri="{386F3935-93C4-4BCD-93E2-E3B085C9AB24}">
+                <p16:designElem xmlns:p16="http://schemas.microsoft.com/office/powerpoint/2015/main" val="1"/>
+              </p:ext>
+            </p:extLst>
+          </p:nvPr>
+        </p:nvPicPr>
+        <p:blipFill>
+          <a:blip r:embed="rId3">
+            <a:extLst>
+              <a:ext uri="{28A0092B-C50C-407E-A947-70E740481C1C}">
+                <a14:useLocalDpi xmlns:a14="http://schemas.microsoft.com/office/drawing/2010/main" val="0"/>
+              </a:ext>
+            </a:extLst>
+          </a:blip>
+          <a:stretch>
+            <a:fillRect/>
+          </a:stretch>
+        </p:blipFill>
+        <p:spPr>
+          <a:xfrm>
+            <a:off x="628022" y="547807"/>
+            <a:ext cx="10935956" cy="3816806"/>
+          </a:xfrm>
+          <a:prstGeom prst="rect">
+            <a:avLst/>
+          </a:prstGeom>
+        </p:spPr>
+      </p:pic>
+      <p:pic>
+        <p:nvPicPr>
+          <p:cNvPr id="4" name="Picture 3">
+            <a:extLst>
+              <a:ext uri="{FF2B5EF4-FFF2-40B4-BE49-F238E27FC236}">
+                <a16:creationId xmlns:a16="http://schemas.microsoft.com/office/drawing/2014/main" id="{57486B99-E6D1-CA3D-E1FD-664902263CD0}"/>
+              </a:ext>
+            </a:extLst>
+          </p:cNvPr>
+          <p:cNvPicPr>
+            <a:picLocks noChangeAspect="1"/>
+          </p:cNvPicPr>
+          <p:nvPr/>
+        </p:nvPicPr>
+        <p:blipFill>
+          <a:blip r:embed="rId4">
+            <a:extLst>
+              <a:ext uri="{28A0092B-C50C-407E-A947-70E740481C1C}">
+                <a14:useLocalDpi xmlns:a14="http://schemas.microsoft.com/office/drawing/2010/main" val="0"/>
+              </a:ext>
+            </a:extLst>
+          </a:blip>
+          <a:stretch>
+            <a:fillRect/>
+          </a:stretch>
+        </p:blipFill>
+        <p:spPr>
+          <a:xfrm>
+            <a:off x="913795" y="1173329"/>
+            <a:ext cx="5101771" cy="2550885"/>
+          </a:xfrm>
+          <a:prstGeom prst="rect">
+            <a:avLst/>
+          </a:prstGeom>
+        </p:spPr>
+      </p:pic>
+      <p:pic>
+        <p:nvPicPr>
+          <p:cNvPr id="8" name="Picture 7">
+            <a:extLst>
+              <a:ext uri="{FF2B5EF4-FFF2-40B4-BE49-F238E27FC236}">
+                <a16:creationId xmlns:a16="http://schemas.microsoft.com/office/drawing/2014/main" id="{1ED0BD3C-04E2-2E01-5530-310E6BC6FD41}"/>
+              </a:ext>
+            </a:extLst>
+          </p:cNvPr>
+          <p:cNvPicPr>
+            <a:picLocks noChangeAspect="1"/>
+          </p:cNvPicPr>
+          <p:nvPr/>
+        </p:nvPicPr>
+        <p:blipFill>
+          <a:blip r:embed="rId5">
+            <a:extLst>
+              <a:ext uri="{28A0092B-C50C-407E-A947-70E740481C1C}">
+                <a14:useLocalDpi xmlns:a14="http://schemas.microsoft.com/office/drawing/2010/main" val="0"/>
+              </a:ext>
+            </a:extLst>
+          </a:blip>
+          <a:stretch>
+            <a:fillRect/>
+          </a:stretch>
+        </p:blipFill>
+        <p:spPr>
+          <a:xfrm>
+            <a:off x="6170821" y="1173184"/>
+            <a:ext cx="5102352" cy="2551176"/>
+          </a:xfrm>
+          <a:prstGeom prst="rect">
+            <a:avLst/>
+          </a:prstGeom>
+        </p:spPr>
+      </p:pic>
     </p:spTree>
     <p:extLst>
       <p:ext uri="{BB962C8B-B14F-4D97-AF65-F5344CB8AC3E}">
@@ -6780,6 +6936,25 @@
 <file path=ppt/slides/slide11.xml><?xml version="1.0" encoding="utf-8"?>
 <p:sld xmlns:a="http://schemas.openxmlformats.org/drawingml/2006/main" xmlns:r="http://schemas.openxmlformats.org/officeDocument/2006/relationships" xmlns:p="http://schemas.openxmlformats.org/presentationml/2006/main">
   <p:cSld>
+    <p:bg>
+      <p:bgPr>
+        <a:blipFill rotWithShape="1">
+          <a:blip r:embed="rId2">
+            <a:duotone>
+              <a:schemeClr val="bg2">
+                <a:shade val="80000"/>
+                <a:lumMod val="80000"/>
+              </a:schemeClr>
+              <a:schemeClr val="bg2">
+                <a:tint val="98000"/>
+              </a:schemeClr>
+            </a:duotone>
+          </a:blip>
+          <a:stretch/>
+        </a:blipFill>
+        <a:effectLst/>
+      </p:bgPr>
+    </p:bg>
     <p:spTree>
       <p:nvGrpSpPr>
         <p:cNvPr id="1" name=""/>
@@ -6799,6 +6974,295 @@
           <p:cNvPr id="2" name="Title 1">
             <a:extLst>
               <a:ext uri="{FF2B5EF4-FFF2-40B4-BE49-F238E27FC236}">
+                <a16:creationId xmlns:a16="http://schemas.microsoft.com/office/drawing/2014/main" id="{03BDA74D-CC61-6D03-9ACE-FB42B3048EC9}"/>
+              </a:ext>
+            </a:extLst>
+          </p:cNvPr>
+          <p:cNvSpPr>
+            <a:spLocks noGrp="1"/>
+          </p:cNvSpPr>
+          <p:nvPr>
+            <p:ph type="title"/>
+          </p:nvPr>
+        </p:nvSpPr>
+        <p:spPr>
+          <a:xfrm>
+            <a:off x="861791" y="835383"/>
+            <a:ext cx="3382832" cy="3499549"/>
+          </a:xfrm>
+        </p:spPr>
+        <p:txBody>
+          <a:bodyPr vert="horz" lIns="91440" tIns="45720" rIns="91440" bIns="45720" rtlCol="0" anchor="b">
+            <a:normAutofit/>
+          </a:bodyPr>
+          <a:lstStyle/>
+          <a:p>
+            <a:pPr algn="l"/>
+            <a:r>
+              <a:rPr lang="en-US" sz="4200"/>
+              <a:t>10. Deney Sonuçları:</a:t>
+            </a:r>
+            <a:br>
+              <a:rPr lang="en-US" sz="4200"/>
+            </a:br>
+            <a:r>
+              <a:rPr lang="en-US" sz="4200"/>
+              <a:t>Sıralama Tablosu</a:t>
+            </a:r>
+          </a:p>
+        </p:txBody>
+      </p:sp>
+      <p:pic>
+        <p:nvPicPr>
+          <p:cNvPr id="17" name="Picture 16">
+            <a:extLst>
+              <a:ext uri="{FF2B5EF4-FFF2-40B4-BE49-F238E27FC236}">
+                <a16:creationId xmlns:a16="http://schemas.microsoft.com/office/drawing/2014/main" id="{08187575-5CB4-477B-AA47-020C6D2A786E}"/>
+              </a:ext>
+              <a:ext uri="{C183D7F6-B498-43B3-948B-1728B52AA6E4}">
+                <adec:decorative xmlns:adec="http://schemas.microsoft.com/office/drawing/2017/decorative" val="1"/>
+              </a:ext>
+            </a:extLst>
+          </p:cNvPr>
+          <p:cNvPicPr>
+            <a:picLocks noGrp="1" noRot="1" noChangeAspect="1" noMove="1" noResize="1" noEditPoints="1" noAdjustHandles="1" noChangeArrowheads="1" noChangeShapeType="1" noCrop="1"/>
+          </p:cNvPicPr>
+          <p:nvPr>
+            <p:extLst>
+              <p:ext uri="{386F3935-93C4-4BCD-93E2-E3B085C9AB24}">
+                <p16:designElem xmlns:p16="http://schemas.microsoft.com/office/powerpoint/2015/main" val="1"/>
+              </p:ext>
+            </p:extLst>
+          </p:nvPr>
+        </p:nvPicPr>
+        <p:blipFill rotWithShape="1">
+          <a:blip r:embed="rId3">
+            <a:extLst>
+              <a:ext uri="{28A0092B-C50C-407E-A947-70E740481C1C}">
+                <a14:useLocalDpi xmlns:a14="http://schemas.microsoft.com/office/drawing/2010/main" val="0"/>
+              </a:ext>
+            </a:extLst>
+          </a:blip>
+          <a:srcRect t="964" r="2807" b="1446"/>
+          <a:stretch/>
+        </p:blipFill>
+        <p:spPr>
+          <a:xfrm>
+            <a:off x="4552950" y="1"/>
+            <a:ext cx="7639050" cy="6858000"/>
+          </a:xfrm>
+          <a:prstGeom prst="rect">
+            <a:avLst/>
+          </a:prstGeom>
+        </p:spPr>
+      </p:pic>
+      <p:pic>
+        <p:nvPicPr>
+          <p:cNvPr id="19" name="Picture 18">
+            <a:extLst>
+              <a:ext uri="{FF2B5EF4-FFF2-40B4-BE49-F238E27FC236}">
+                <a16:creationId xmlns:a16="http://schemas.microsoft.com/office/drawing/2014/main" id="{EE585F70-7C5D-424E-A182-39507AF48A0C}"/>
+              </a:ext>
+              <a:ext uri="{C183D7F6-B498-43B3-948B-1728B52AA6E4}">
+                <adec:decorative xmlns:adec="http://schemas.microsoft.com/office/drawing/2017/decorative" val="1"/>
+              </a:ext>
+            </a:extLst>
+          </p:cNvPr>
+          <p:cNvPicPr>
+            <a:picLocks noGrp="1" noRot="1" noChangeAspect="1" noMove="1" noResize="1" noEditPoints="1" noAdjustHandles="1" noChangeArrowheads="1" noChangeShapeType="1" noCrop="1"/>
+          </p:cNvPicPr>
+          <p:nvPr>
+            <p:extLst>
+              <p:ext uri="{386F3935-93C4-4BCD-93E2-E3B085C9AB24}">
+                <p16:designElem xmlns:p16="http://schemas.microsoft.com/office/powerpoint/2015/main" val="1"/>
+              </p:ext>
+            </p:extLst>
+          </p:nvPr>
+        </p:nvPicPr>
+        <p:blipFill rotWithShape="1">
+          <a:blip r:embed="rId3">
+            <a:extLst>
+              <a:ext uri="{28A0092B-C50C-407E-A947-70E740481C1C}">
+                <a14:useLocalDpi xmlns:a14="http://schemas.microsoft.com/office/drawing/2010/main" val="0"/>
+              </a:ext>
+            </a:extLst>
+          </a:blip>
+          <a:srcRect t="964" r="2807" b="1446"/>
+          <a:stretch/>
+        </p:blipFill>
+        <p:spPr>
+          <a:xfrm>
+            <a:off x="7501468" y="1"/>
+            <a:ext cx="4690532" cy="6858000"/>
+          </a:xfrm>
+          <a:prstGeom prst="rect">
+            <a:avLst/>
+          </a:prstGeom>
+        </p:spPr>
+      </p:pic>
+      <p:pic>
+        <p:nvPicPr>
+          <p:cNvPr id="10" name="Picture 9">
+            <a:extLst>
+              <a:ext uri="{FF2B5EF4-FFF2-40B4-BE49-F238E27FC236}">
+                <a16:creationId xmlns:a16="http://schemas.microsoft.com/office/drawing/2014/main" id="{6CE48548-35A5-A363-D6B7-301890A18D28}"/>
+              </a:ext>
+            </a:extLst>
+          </p:cNvPr>
+          <p:cNvPicPr>
+            <a:picLocks noChangeAspect="1"/>
+          </p:cNvPicPr>
+          <p:nvPr/>
+        </p:nvPicPr>
+        <p:blipFill>
+          <a:blip r:embed="rId4">
+            <a:extLst>
+              <a:ext uri="{28A0092B-C50C-407E-A947-70E740481C1C}">
+                <a14:useLocalDpi xmlns:a14="http://schemas.microsoft.com/office/drawing/2010/main" val="0"/>
+              </a:ext>
+            </a:extLst>
+          </a:blip>
+          <a:stretch>
+            <a:fillRect/>
+          </a:stretch>
+        </p:blipFill>
+        <p:spPr>
+          <a:xfrm>
+            <a:off x="6162675" y="16741"/>
+            <a:ext cx="4419600" cy="6824518"/>
+          </a:xfrm>
+          <a:prstGeom prst="rect">
+            <a:avLst/>
+          </a:prstGeom>
+        </p:spPr>
+      </p:pic>
+    </p:spTree>
+    <p:extLst>
+      <p:ext uri="{BB962C8B-B14F-4D97-AF65-F5344CB8AC3E}">
+        <p14:creationId xmlns:p14="http://schemas.microsoft.com/office/powerpoint/2010/main" val="3274986205"/>
+      </p:ext>
+    </p:extLst>
+  </p:cSld>
+  <p:clrMapOvr>
+    <a:masterClrMapping/>
+  </p:clrMapOvr>
+  <p:timing>
+    <p:tnLst>
+      <p:par>
+        <p:cTn id="1" dur="indefinite" restart="never" nodeType="tmRoot">
+          <p:childTnLst>
+            <p:seq concurrent="1" nextAc="seek">
+              <p:cTn id="2" dur="indefinite" nodeType="mainSeq">
+                <p:childTnLst>
+                  <p:par>
+                    <p:cTn id="3" fill="hold">
+                      <p:stCondLst>
+                        <p:cond delay="indefinite"/>
+                        <p:cond evt="onBegin" delay="0">
+                          <p:tn val="2"/>
+                        </p:cond>
+                      </p:stCondLst>
+                      <p:childTnLst>
+                        <p:par>
+                          <p:cTn id="4" fill="hold">
+                            <p:stCondLst>
+                              <p:cond delay="0"/>
+                            </p:stCondLst>
+                            <p:childTnLst>
+                              <p:par>
+                                <p:cTn id="5" presetID="10" presetClass="entr" presetSubtype="0" fill="hold" grpId="0" nodeType="withEffect">
+                                  <p:stCondLst>
+                                    <p:cond delay="1000"/>
+                                  </p:stCondLst>
+                                  <p:iterate>
+                                    <p:tmPct val="10000"/>
+                                  </p:iterate>
+                                  <p:childTnLst>
+                                    <p:set>
+                                      <p:cBhvr>
+                                        <p:cTn id="6" dur="1" fill="hold">
+                                          <p:stCondLst>
+                                            <p:cond delay="0"/>
+                                          </p:stCondLst>
+                                        </p:cTn>
+                                        <p:tgtEl>
+                                          <p:spTgt spid="2"/>
+                                        </p:tgtEl>
+                                        <p:attrNameLst>
+                                          <p:attrName>style.visibility</p:attrName>
+                                        </p:attrNameLst>
+                                      </p:cBhvr>
+                                      <p:to>
+                                        <p:strVal val="visible"/>
+                                      </p:to>
+                                    </p:set>
+                                    <p:animEffect transition="in" filter="fade">
+                                      <p:cBhvr>
+                                        <p:cTn id="7" dur="700"/>
+                                        <p:tgtEl>
+                                          <p:spTgt spid="2"/>
+                                        </p:tgtEl>
+                                      </p:cBhvr>
+                                    </p:animEffect>
+                                  </p:childTnLst>
+                                </p:cTn>
+                              </p:par>
+                            </p:childTnLst>
+                          </p:cTn>
+                        </p:par>
+                      </p:childTnLst>
+                    </p:cTn>
+                  </p:par>
+                </p:childTnLst>
+              </p:cTn>
+              <p:prevCondLst>
+                <p:cond evt="onPrev" delay="0">
+                  <p:tgtEl>
+                    <p:sldTgt/>
+                  </p:tgtEl>
+                </p:cond>
+              </p:prevCondLst>
+              <p:nextCondLst>
+                <p:cond evt="onNext" delay="0">
+                  <p:tgtEl>
+                    <p:sldTgt/>
+                  </p:tgtEl>
+                </p:cond>
+              </p:nextCondLst>
+            </p:seq>
+          </p:childTnLst>
+        </p:cTn>
+      </p:par>
+    </p:tnLst>
+    <p:bldLst>
+      <p:bldP spid="2" grpId="0"/>
+    </p:bldLst>
+  </p:timing>
+</p:sld>
+</file>
+
+<file path=ppt/slides/slide12.xml><?xml version="1.0" encoding="utf-8"?>
+<p:sld xmlns:a="http://schemas.openxmlformats.org/drawingml/2006/main" xmlns:r="http://schemas.openxmlformats.org/officeDocument/2006/relationships" xmlns:p="http://schemas.openxmlformats.org/presentationml/2006/main">
+  <p:cSld>
+    <p:spTree>
+      <p:nvGrpSpPr>
+        <p:cNvPr id="1" name=""/>
+        <p:cNvGrpSpPr/>
+        <p:nvPr/>
+      </p:nvGrpSpPr>
+      <p:grpSpPr>
+        <a:xfrm>
+          <a:off x="0" y="0"/>
+          <a:ext cx="0" cy="0"/>
+          <a:chOff x="0" y="0"/>
+          <a:chExt cx="0" cy="0"/>
+        </a:xfrm>
+      </p:grpSpPr>
+      <p:sp>
+        <p:nvSpPr>
+          <p:cNvPr id="2" name="Title 1">
+            <a:extLst>
+              <a:ext uri="{FF2B5EF4-FFF2-40B4-BE49-F238E27FC236}">
                 <a16:creationId xmlns:a16="http://schemas.microsoft.com/office/drawing/2014/main" id="{102A5A02-C387-3EEE-1C98-6F255751CF92}"/>
               </a:ext>
             </a:extLst>
@@ -6817,7 +7281,7 @@
           <a:p>
             <a:r>
               <a:rPr lang="tr-TR" dirty="0"/>
-              <a:t>Gelecek Çalışmalar</a:t>
+              <a:t>11. Gelecek Çalışmalar</a:t>
             </a:r>
           </a:p>
         </p:txBody>
@@ -7784,21 +8248,21 @@
           <a:p>
             <a:r>
               <a:rPr lang="tr-TR" dirty="0"/>
-              <a:t>Ara epochlardaki sıralamalar ile bu “en iyi sıralama” Spearman korelasyonu kullanılarak karşılaştırılmıştır.</a:t>
+              <a:t>Ara epochlardaki sıralamalar ile bu “en iyi sıralama” karşılaştırılmıştır.</a:t>
             </a:r>
           </a:p>
           <a:p>
             <a:pPr lvl="1"/>
             <a:r>
               <a:rPr lang="tr-TR" dirty="0"/>
-              <a:t>Hem tüm modellerin sıralamaları</a:t>
+              <a:t>Tüm modellerin sıralamaları Spearman Korelasyonu ile analiz edilmiş,</a:t>
             </a:r>
           </a:p>
           <a:p>
             <a:pPr lvl="1"/>
             <a:r>
               <a:rPr lang="tr-TR" dirty="0"/>
-              <a:t>Hem de sadece en iyi 3 modelin sıralamaları için ayrı analiz yapılmıştır</a:t>
+              <a:t>Sadece en iyi 3 model için Top 3 Overlap analizi yapılmıştır</a:t>
             </a:r>
           </a:p>
         </p:txBody>
@@ -7819,6 +8283,25 @@
 <file path=ppt/slides/slide8.xml><?xml version="1.0" encoding="utf-8"?>
 <p:sld xmlns:a="http://schemas.openxmlformats.org/drawingml/2006/main" xmlns:r="http://schemas.openxmlformats.org/officeDocument/2006/relationships" xmlns:p="http://schemas.openxmlformats.org/presentationml/2006/main">
   <p:cSld>
+    <p:bg>
+      <p:bgPr>
+        <a:blipFill rotWithShape="1">
+          <a:blip r:embed="rId2">
+            <a:duotone>
+              <a:schemeClr val="bg2">
+                <a:shade val="80000"/>
+                <a:lumMod val="80000"/>
+              </a:schemeClr>
+              <a:schemeClr val="bg2">
+                <a:tint val="98000"/>
+              </a:schemeClr>
+            </a:duotone>
+          </a:blip>
+          <a:stretch/>
+        </a:blipFill>
+        <a:effectLst/>
+      </p:bgPr>
+    </p:bg>
     <p:spTree>
       <p:nvGrpSpPr>
         <p:cNvPr id="1" name=""/>
@@ -7849,9 +8332,16 @@
             <p:ph type="title"/>
           </p:nvPr>
         </p:nvSpPr>
-        <p:spPr/>
-        <p:txBody>
-          <a:bodyPr/>
+        <p:spPr>
+          <a:xfrm>
+            <a:off x="913795" y="609600"/>
+            <a:ext cx="5978072" cy="1329596"/>
+          </a:xfrm>
+        </p:spPr>
+        <p:txBody>
+          <a:bodyPr>
+            <a:normAutofit/>
+          </a:bodyPr>
           <a:lstStyle/>
           <a:p>
             <a:r>
@@ -7877,9 +8367,16 @@
             <p:ph idx="1"/>
           </p:nvPr>
         </p:nvSpPr>
-        <p:spPr/>
-        <p:txBody>
-          <a:bodyPr/>
+        <p:spPr>
+          <a:xfrm>
+            <a:off x="913795" y="2127623"/>
+            <a:ext cx="5978072" cy="3567225"/>
+          </a:xfrm>
+        </p:spPr>
+        <p:txBody>
+          <a:bodyPr anchor="ctr">
+            <a:normAutofit/>
+          </a:bodyPr>
           <a:lstStyle/>
           <a:p>
             <a:pPr marL="36900" indent="0">
@@ -7938,6 +8435,87 @@
           </a:p>
         </p:txBody>
       </p:sp>
+      <p:pic>
+        <p:nvPicPr>
+          <p:cNvPr id="10" name="Picture 9">
+            <a:extLst>
+              <a:ext uri="{FF2B5EF4-FFF2-40B4-BE49-F238E27FC236}">
+                <a16:creationId xmlns:a16="http://schemas.microsoft.com/office/drawing/2014/main" id="{7AEE9CAC-347C-43C2-AE87-6BC5566E6068}"/>
+              </a:ext>
+              <a:ext uri="{C183D7F6-B498-43B3-948B-1728B52AA6E4}">
+                <adec:decorative xmlns:adec="http://schemas.microsoft.com/office/drawing/2017/decorative" val="1"/>
+              </a:ext>
+            </a:extLst>
+          </p:cNvPr>
+          <p:cNvPicPr>
+            <a:picLocks noGrp="1" noRot="1" noChangeAspect="1" noMove="1" noResize="1" noEditPoints="1" noAdjustHandles="1" noChangeArrowheads="1" noChangeShapeType="1" noCrop="1"/>
+          </p:cNvPicPr>
+          <p:nvPr>
+            <p:extLst>
+              <p:ext uri="{386F3935-93C4-4BCD-93E2-E3B085C9AB24}">
+                <p16:designElem xmlns:p16="http://schemas.microsoft.com/office/powerpoint/2015/main" val="1"/>
+              </p:ext>
+            </p:extLst>
+          </p:nvPr>
+        </p:nvPicPr>
+        <p:blipFill rotWithShape="1">
+          <a:blip r:embed="rId3">
+            <a:extLst>
+              <a:ext uri="{28A0092B-C50C-407E-A947-70E740481C1C}">
+                <a14:useLocalDpi xmlns:a14="http://schemas.microsoft.com/office/drawing/2010/main" val="0"/>
+              </a:ext>
+            </a:extLst>
+          </a:blip>
+          <a:srcRect t="964" r="2807" b="1446"/>
+          <a:stretch/>
+        </p:blipFill>
+        <p:spPr>
+          <a:xfrm>
+            <a:off x="7232905" y="1"/>
+            <a:ext cx="4959095" cy="6858000"/>
+          </a:xfrm>
+          <a:prstGeom prst="rect">
+            <a:avLst/>
+          </a:prstGeom>
+        </p:spPr>
+      </p:pic>
+      <p:pic>
+        <p:nvPicPr>
+          <p:cNvPr id="5" name="Picture 4">
+            <a:extLst>
+              <a:ext uri="{FF2B5EF4-FFF2-40B4-BE49-F238E27FC236}">
+                <a16:creationId xmlns:a16="http://schemas.microsoft.com/office/drawing/2014/main" id="{A7F32925-0D14-8B3E-0216-08AD9FA1B894}"/>
+              </a:ext>
+            </a:extLst>
+          </p:cNvPr>
+          <p:cNvPicPr>
+            <a:picLocks noChangeAspect="1"/>
+          </p:cNvPicPr>
+          <p:nvPr/>
+        </p:nvPicPr>
+        <p:blipFill>
+          <a:blip r:embed="rId4">
+            <a:extLst>
+              <a:ext uri="{28A0092B-C50C-407E-A947-70E740481C1C}">
+                <a14:useLocalDpi xmlns:a14="http://schemas.microsoft.com/office/drawing/2010/main" val="0"/>
+              </a:ext>
+            </a:extLst>
+          </a:blip>
+          <a:srcRect l="3563" t="3548" r="3338" b="3236"/>
+          <a:stretch>
+            <a:fillRect/>
+          </a:stretch>
+        </p:blipFill>
+        <p:spPr>
+          <a:xfrm>
+            <a:off x="7410047" y="1181100"/>
+            <a:ext cx="4686703" cy="4692650"/>
+          </a:xfrm>
+          <a:prstGeom prst="rect">
+            <a:avLst/>
+          </a:prstGeom>
+        </p:spPr>
+      </p:pic>
     </p:spTree>
     <p:extLst>
       <p:ext uri="{BB962C8B-B14F-4D97-AF65-F5344CB8AC3E}">
@@ -8005,25 +8583,36 @@
         </p:nvSpPr>
         <p:spPr>
           <a:xfrm>
-            <a:off x="1370693" y="4511814"/>
+            <a:off x="1375983" y="4835664"/>
             <a:ext cx="9440034" cy="1130260"/>
           </a:xfrm>
         </p:spPr>
         <p:txBody>
           <a:bodyPr vert="horz" lIns="91440" tIns="45720" rIns="91440" bIns="45720" rtlCol="0" anchor="b">
-            <a:normAutofit/>
+            <a:noAutofit/>
           </a:bodyPr>
           <a:lstStyle/>
           <a:p>
             <a:r>
-              <a:rPr lang="en-US" sz="4800" dirty="0"/>
+              <a:rPr lang="en-US" sz="3200" dirty="0"/>
               <a:t>8. Deney </a:t>
             </a:r>
             <a:r>
-              <a:rPr lang="en-US" sz="4800" dirty="0" err="1"/>
+              <a:rPr lang="en-US" sz="3200" dirty="0" err="1"/>
               <a:t>Sonuçları</a:t>
             </a:r>
-            <a:endParaRPr lang="en-US" sz="4800" dirty="0"/>
+            <a:r>
+              <a:rPr lang="tr-TR" sz="3200" dirty="0"/>
+              <a:t>:</a:t>
+            </a:r>
+            <a:br>
+              <a:rPr lang="tr-TR" sz="3200" dirty="0"/>
+            </a:br>
+            <a:r>
+              <a:rPr lang="tr-TR" sz="3200" dirty="0"/>
+              <a:t>Validation Accuracy – Loss Grafikleri</a:t>
+            </a:r>
+            <a:endParaRPr lang="en-US" sz="3200" dirty="0"/>
           </a:p>
         </p:txBody>
       </p:sp>

</xml_diff>